<commit_message>
feat: update Copilot infographic courseware
</commit_message>
<xml_diff>
--- a/activities/Activity-01-Decode-a-Customer-Survey-Infographic/A01-Decode-a-Customer-Survey-Infographic-Sample.pptx
+++ b/activities/Activity-01-Decode-a-Customer-Survey-Infographic/A01-Decode-a-Customer-Survey-Infographic-Sample.pptx
@@ -11,6 +11,7 @@
     <p:sldId id="259" r:id="rId10"/>
     <p:sldId id="260" r:id="rId11"/>
     <p:sldId id="261" r:id="rId12"/>
+    <p:sldId id="262" r:id="rId13"/>
   </p:sldIdLst>
   <p:sldSz cx="12191695" cy="6858000" type="screen4x3"/>
   <p:notesSz cx="6858000" cy="9144000"/>
@@ -3293,7 +3294,7 @@
                 </a:solidFill>
                 <a:latin typeface="Arial"/>
               </a:rPr>
-              <a:t>Use AI to Clean Data and Extract Insights</a:t>
+              <a:t>Interpret a Statistical KPI Infographic</a:t>
             </a:r>
           </a:p>
         </p:txBody>
@@ -3443,7 +3444,7 @@
                 </a:solidFill>
                 <a:latin typeface="Arial"/>
               </a:rPr>
-              <a:t>Approved AI assistant + Excel + PowerPoint</a:t>
+              <a:t>Microsoft 365 Copilot + Excel + PowerPoint</a:t>
             </a:r>
           </a:p>
         </p:txBody>
@@ -3906,7 +3907,7 @@
                 </a:solidFill>
                 <a:latin typeface="Arial"/>
               </a:rPr>
-              <a:t>Data analyst</a:t>
+              <a:t>Analyse the evidence</a:t>
             </a:r>
           </a:p>
         </p:txBody>
@@ -3941,7 +3942,7 @@
                 </a:solidFill>
                 <a:latin typeface="Arial"/>
               </a:rPr>
-              <a:t>Using only the attached approved sources, create a source register, identify duplicates or conflicting definitions, clean the table, show formulas or transformations, and return five candidate insights with citations, caveats and a con…</a:t>
+              <a:t>Using only the attached approved source, identify the three strongest patterns, the denominator for each metric, one limitation and one proportionate business action. Cite the source field or row for every number. Do not invent missing…</a:t>
             </a:r>
           </a:p>
         </p:txBody>
@@ -4146,7 +4147,7 @@
                 </a:solidFill>
                 <a:latin typeface="Arial"/>
               </a:rPr>
-              <a:t>Infographic</a:t>
+              <a:t>Create the infographic</a:t>
             </a:r>
           </a:p>
         </p:txBody>
@@ -4181,7 +4182,7 @@
                 </a:solidFill>
                 <a:latin typeface="Arial"/>
               </a:rPr>
-              <a:t>Create a one-page executive infographic for Singapore retail managers. Lead with one decision insight, show three supporting metrics, include a five-stage flow and a source footer. Use a clean professional style, strong hierarchy and n…</a:t>
+              <a:t>Create a one-page [TYPE] infographic about [TOPIC]. Sections: 1. [SECTION ONE] 2. [SECTION TWO] 3. [SECTION THREE] 4. [SECTION FOUR] 5. [SECTION FIVE]. Audience: [AUDIENCE]. Decision: [DECISION]. Style: professional, high contrast, con…</a:t>
             </a:r>
           </a:p>
         </p:txBody>
@@ -4386,7 +4387,7 @@
                 </a:solidFill>
                 <a:latin typeface="Arial"/>
               </a:rPr>
-              <a:t>Text to image</a:t>
+              <a:t>Refine in PowerPoint</a:t>
             </a:r>
           </a:p>
         </p:txBody>
@@ -4421,7 +4422,7 @@
                 </a:solidFill>
                 <a:latin typeface="Arial"/>
               </a:rPr>
-              <a:t>Create a clean vector-like sustainability delivery illustration for a PowerPoint infographic: one electric van, one reusable parcel, a simple route and a feedback symbol. Transparent background, consistent blue/teal/violet/amber palett…</a:t>
+              <a:t>Turn the selected infographic direction into one editable PowerPoint slide. Keep the action title, labels, numbers, chart or process, source footer and accessibility notes editable. Remove decoration that does not support the message. …</a:t>
             </a:r>
           </a:p>
         </p:txBody>
@@ -4626,7 +4627,7 @@
                 </a:solidFill>
                 <a:latin typeface="Arial"/>
               </a:rPr>
-              <a:t>Gemini Notebook deck</a:t>
+              <a:t>Quality review</a:t>
             </a:r>
           </a:p>
         </p:txBody>
@@ -4661,7 +4662,7 @@
                 </a:solidFill>
                 <a:latin typeface="Arial"/>
               </a:rPr>
-              <a:t>Create Presenter Slides for business stakeholders. Focus on the verified decision insight, use a concise professional style, include source-grounded comparisons and a final recommendation. Avoid claims not supported by selected sources…</a:t>
+              <a:t>Review this infographic against message clarity, data accuracy, visual hierarchy, audience fit, accessibility, editability and business goal. List each issue with evidence, its impact, the proposed change and a pass/fail acceptance che…</a:t>
             </a:r>
           </a:p>
         </p:txBody>
@@ -4744,11 +4745,11 @@
             <a:avLst/>
           </a:prstGeom>
           <a:solidFill>
-            <a:srgbClr val="1F6FEB"/>
+            <a:srgbClr val="7C3AED"/>
           </a:solidFill>
           <a:ln>
             <a:solidFill>
-              <a:srgbClr val="1F6FEB"/>
+              <a:srgbClr val="7C3AED"/>
             </a:solidFill>
           </a:ln>
         </p:spPr>
@@ -4800,11 +4801,11 @@
             <a:r>
               <a:rPr sz="1100" b="1">
                 <a:solidFill>
-                  <a:srgbClr val="1F6FEB"/>
+                  <a:srgbClr val="7C3AED"/>
                 </a:solidFill>
                 <a:latin typeface="Arial"/>
               </a:rPr>
-              <a:t>ACTIVITY 01 · CONTEXT</a:t>
+              <a:t>ACTIVITY 01 · COPY, ADAPT AND VERIFY</a:t>
             </a:r>
           </a:p>
         </p:txBody>
@@ -4839,7 +4840,7 @@
                 </a:solidFill>
                 <a:latin typeface="Arial"/>
               </a:rPr>
-              <a:t>The Scenario</a:t>
+              <a:t>Structured Microsoft 365 Copilot Prompt</a:t>
             </a:r>
           </a:p>
         </p:txBody>
@@ -4932,8 +4933,8 @@
         </p:nvSpPr>
         <p:spPr>
           <a:xfrm>
-            <a:off x="731520" y="1783080"/>
-            <a:ext cx="10698480" cy="1691640"/>
+            <a:off x="749808" y="1700784"/>
+            <a:ext cx="10698480" cy="4370832"/>
           </a:xfrm>
           <a:prstGeom prst="roundRect">
             <a:avLst/>
@@ -4971,104 +4972,14 @@
       </p:sp>
       <p:sp>
         <p:nvSpPr>
-          <p:cNvPr id="9" name="Rectangle 8"/>
-          <p:cNvSpPr/>
-          <p:nvPr/>
-        </p:nvSpPr>
-        <p:spPr>
-          <a:xfrm>
-            <a:off x="731520" y="1783080"/>
-            <a:ext cx="73152" cy="1691640"/>
-          </a:xfrm>
-          <a:prstGeom prst="rect">
-            <a:avLst/>
-          </a:prstGeom>
-          <a:solidFill>
-            <a:srgbClr val="1F6FEB"/>
-          </a:solidFill>
-          <a:ln>
-            <a:solidFill>
-              <a:srgbClr val="1F6FEB"/>
-            </a:solidFill>
-          </a:ln>
-        </p:spPr>
-        <p:style>
-          <a:lnRef idx="1">
-            <a:schemeClr val="accent1"/>
-          </a:lnRef>
-          <a:fillRef idx="3">
-            <a:schemeClr val="accent1"/>
-          </a:fillRef>
-          <a:effectRef idx="2">
-            <a:schemeClr val="accent1"/>
-          </a:effectRef>
-          <a:fontRef idx="minor">
-            <a:schemeClr val="lt1"/>
-          </a:fontRef>
-        </p:style>
-        <p:txBody>
-          <a:bodyPr rtlCol="0" anchor="ctr"/>
-          <a:lstStyle/>
-          <a:p>
-            <a:pPr algn="ctr"/>
-          </a:p>
-        </p:txBody>
-      </p:sp>
-      <p:sp>
-        <p:nvSpPr>
-          <p:cNvPr id="10" name="Rounded Rectangle 9"/>
-          <p:cNvSpPr/>
-          <p:nvPr/>
-        </p:nvSpPr>
-        <p:spPr>
-          <a:xfrm>
-            <a:off x="932688" y="2002536"/>
-            <a:ext cx="438912" cy="438912"/>
-          </a:xfrm>
-          <a:prstGeom prst="roundRect">
-            <a:avLst/>
-          </a:prstGeom>
-          <a:solidFill>
-            <a:srgbClr val="1F6FEB"/>
-          </a:solidFill>
-          <a:ln>
-            <a:solidFill>
-              <a:srgbClr val="1F6FEB"/>
-            </a:solidFill>
-          </a:ln>
-        </p:spPr>
-        <p:style>
-          <a:lnRef idx="1">
-            <a:schemeClr val="accent1"/>
-          </a:lnRef>
-          <a:fillRef idx="3">
-            <a:schemeClr val="accent1"/>
-          </a:fillRef>
-          <a:effectRef idx="2">
-            <a:schemeClr val="accent1"/>
-          </a:effectRef>
-          <a:fontRef idx="minor">
-            <a:schemeClr val="lt1"/>
-          </a:fontRef>
-        </p:style>
-        <p:txBody>
-          <a:bodyPr rtlCol="0" anchor="ctr"/>
-          <a:lstStyle/>
-          <a:p>
-            <a:pPr algn="ctr"/>
-          </a:p>
-        </p:txBody>
-      </p:sp>
-      <p:sp>
-        <p:nvSpPr>
-          <p:cNvPr id="11" name="TextBox 10"/>
+          <p:cNvPr id="9" name="TextBox 8"/>
           <p:cNvSpPr txBox="1"/>
           <p:nvPr/>
         </p:nvSpPr>
         <p:spPr>
           <a:xfrm>
-            <a:off x="932688" y="2011680"/>
-            <a:ext cx="438912" cy="420624"/>
+            <a:off x="960120" y="1874519"/>
+            <a:ext cx="384048" cy="246888"/>
           </a:xfrm>
           <a:prstGeom prst="rect">
             <a:avLst/>
@@ -5076,16 +4987,16 @@
           <a:noFill/>
         </p:spPr>
         <p:txBody>
-          <a:bodyPr wrap="square" anchor="ctr">
+          <a:bodyPr wrap="square" anchor="t">
             <a:spAutoFit/>
           </a:bodyPr>
           <a:lstStyle/>
           <a:p>
-            <a:pPr algn="ctr"/>
-            <a:r>
-              <a:rPr sz="1400" b="1">
-                <a:solidFill>
-                  <a:srgbClr val="FFFFFF"/>
+            <a:pPr algn="r"/>
+            <a:r>
+              <a:rPr sz="900" b="0">
+                <a:solidFill>
+                  <a:srgbClr val="5B6372"/>
                 </a:solidFill>
                 <a:latin typeface="Arial"/>
               </a:rPr>
@@ -5096,14 +5007,14 @@
       </p:sp>
       <p:sp>
         <p:nvSpPr>
-          <p:cNvPr id="12" name="TextBox 11"/>
+          <p:cNvPr id="10" name="TextBox 9"/>
           <p:cNvSpPr txBox="1"/>
           <p:nvPr/>
         </p:nvSpPr>
         <p:spPr>
           <a:xfrm>
-            <a:off x="1536192" y="1965960"/>
-            <a:ext cx="9710928" cy="329184"/>
+            <a:off x="1554480" y="1874519"/>
+            <a:ext cx="9418320" cy="256032"/>
           </a:xfrm>
           <a:prstGeom prst="rect">
             <a:avLst/>
@@ -5118,27 +5029,27 @@
           <a:p>
             <a:pPr algn="l"/>
             <a:r>
-              <a:rPr sz="1400" b="1">
-                <a:solidFill>
-                  <a:srgbClr val="1F6FEB"/>
+              <a:rPr sz="1050" b="0">
+                <a:solidFill>
+                  <a:srgbClr val="161B26"/>
                 </a:solidFill>
                 <a:latin typeface="Arial"/>
               </a:rPr>
-              <a:t>Context</a:t>
-            </a:r>
-          </a:p>
-        </p:txBody>
-      </p:sp>
-      <p:sp>
-        <p:nvSpPr>
-          <p:cNvPr id="13" name="TextBox 12"/>
+              <a:t>Create a one-page statistical KPI infographic about Interpret a Statistical KPI Infographic.</a:t>
+            </a:r>
+          </a:p>
+        </p:txBody>
+      </p:sp>
+      <p:sp>
+        <p:nvSpPr>
+          <p:cNvPr id="11" name="TextBox 10"/>
           <p:cNvSpPr txBox="1"/>
           <p:nvPr/>
         </p:nvSpPr>
         <p:spPr>
           <a:xfrm>
-            <a:off x="1536192" y="2350008"/>
-            <a:ext cx="9710928" cy="978408"/>
+            <a:off x="960120" y="2157984"/>
+            <a:ext cx="384048" cy="246888"/>
           </a:xfrm>
           <a:prstGeom prst="rect">
             <a:avLst/>
@@ -5151,181 +5062,11 @@
           </a:bodyPr>
           <a:lstStyle/>
           <a:p>
-            <a:pPr algn="l"/>
-            <a:r>
-              <a:rPr sz="1150" b="0">
-                <a:solidFill>
-                  <a:srgbClr val="161B26"/>
-                </a:solidFill>
-                <a:latin typeface="Arial"/>
-              </a:rPr>
-              <a:t>Northstar Retail's marketing lead has a one-page customer survey infographic built from 420 synthetic Q2 responses. Leadership wants to know which customer experience deserves further investigation.</a:t>
-            </a:r>
-          </a:p>
-        </p:txBody>
-      </p:sp>
-      <p:sp>
-        <p:nvSpPr>
-          <p:cNvPr id="14" name="Rounded Rectangle 13"/>
-          <p:cNvSpPr/>
-          <p:nvPr/>
-        </p:nvSpPr>
-        <p:spPr>
-          <a:xfrm>
-            <a:off x="731520" y="3776472"/>
-            <a:ext cx="10698480" cy="1691640"/>
-          </a:xfrm>
-          <a:prstGeom prst="roundRect">
-            <a:avLst/>
-          </a:prstGeom>
-          <a:solidFill>
-            <a:srgbClr val="F5F8FC"/>
-          </a:solidFill>
-          <a:ln>
-            <a:solidFill>
-              <a:srgbClr val="E2E8F0"/>
-            </a:solidFill>
-          </a:ln>
-        </p:spPr>
-        <p:style>
-          <a:lnRef idx="1">
-            <a:schemeClr val="accent1"/>
-          </a:lnRef>
-          <a:fillRef idx="3">
-            <a:schemeClr val="accent1"/>
-          </a:fillRef>
-          <a:effectRef idx="2">
-            <a:schemeClr val="accent1"/>
-          </a:effectRef>
-          <a:fontRef idx="minor">
-            <a:schemeClr val="lt1"/>
-          </a:fontRef>
-        </p:style>
-        <p:txBody>
-          <a:bodyPr rtlCol="0" anchor="ctr"/>
-          <a:lstStyle/>
-          <a:p>
-            <a:pPr algn="ctr"/>
-          </a:p>
-        </p:txBody>
-      </p:sp>
-      <p:sp>
-        <p:nvSpPr>
-          <p:cNvPr id="15" name="Rectangle 14"/>
-          <p:cNvSpPr/>
-          <p:nvPr/>
-        </p:nvSpPr>
-        <p:spPr>
-          <a:xfrm>
-            <a:off x="731520" y="3776472"/>
-            <a:ext cx="73152" cy="1691640"/>
-          </a:xfrm>
-          <a:prstGeom prst="rect">
-            <a:avLst/>
-          </a:prstGeom>
-          <a:solidFill>
-            <a:srgbClr val="10B981"/>
-          </a:solidFill>
-          <a:ln>
-            <a:solidFill>
-              <a:srgbClr val="10B981"/>
-            </a:solidFill>
-          </a:ln>
-        </p:spPr>
-        <p:style>
-          <a:lnRef idx="1">
-            <a:schemeClr val="accent1"/>
-          </a:lnRef>
-          <a:fillRef idx="3">
-            <a:schemeClr val="accent1"/>
-          </a:fillRef>
-          <a:effectRef idx="2">
-            <a:schemeClr val="accent1"/>
-          </a:effectRef>
-          <a:fontRef idx="minor">
-            <a:schemeClr val="lt1"/>
-          </a:fontRef>
-        </p:style>
-        <p:txBody>
-          <a:bodyPr rtlCol="0" anchor="ctr"/>
-          <a:lstStyle/>
-          <a:p>
-            <a:pPr algn="ctr"/>
-          </a:p>
-        </p:txBody>
-      </p:sp>
-      <p:sp>
-        <p:nvSpPr>
-          <p:cNvPr id="16" name="Rounded Rectangle 15"/>
-          <p:cNvSpPr/>
-          <p:nvPr/>
-        </p:nvSpPr>
-        <p:spPr>
-          <a:xfrm>
-            <a:off x="932688" y="3995928"/>
-            <a:ext cx="438912" cy="438912"/>
-          </a:xfrm>
-          <a:prstGeom prst="roundRect">
-            <a:avLst/>
-          </a:prstGeom>
-          <a:solidFill>
-            <a:srgbClr val="10B981"/>
-          </a:solidFill>
-          <a:ln>
-            <a:solidFill>
-              <a:srgbClr val="10B981"/>
-            </a:solidFill>
-          </a:ln>
-        </p:spPr>
-        <p:style>
-          <a:lnRef idx="1">
-            <a:schemeClr val="accent1"/>
-          </a:lnRef>
-          <a:fillRef idx="3">
-            <a:schemeClr val="accent1"/>
-          </a:fillRef>
-          <a:effectRef idx="2">
-            <a:schemeClr val="accent1"/>
-          </a:effectRef>
-          <a:fontRef idx="minor">
-            <a:schemeClr val="lt1"/>
-          </a:fontRef>
-        </p:style>
-        <p:txBody>
-          <a:bodyPr rtlCol="0" anchor="ctr"/>
-          <a:lstStyle/>
-          <a:p>
-            <a:pPr algn="ctr"/>
-          </a:p>
-        </p:txBody>
-      </p:sp>
-      <p:sp>
-        <p:nvSpPr>
-          <p:cNvPr id="17" name="TextBox 16"/>
-          <p:cNvSpPr txBox="1"/>
-          <p:nvPr/>
-        </p:nvSpPr>
-        <p:spPr>
-          <a:xfrm>
-            <a:off x="932688" y="4005072"/>
-            <a:ext cx="438912" cy="420624"/>
-          </a:xfrm>
-          <a:prstGeom prst="rect">
-            <a:avLst/>
-          </a:prstGeom>
-          <a:noFill/>
-        </p:spPr>
-        <p:txBody>
-          <a:bodyPr wrap="square" anchor="ctr">
-            <a:spAutoFit/>
-          </a:bodyPr>
-          <a:lstStyle/>
-          <a:p>
-            <a:pPr algn="ctr"/>
-            <a:r>
-              <a:rPr sz="1400" b="1">
-                <a:solidFill>
-                  <a:srgbClr val="FFFFFF"/>
+            <a:pPr algn="r"/>
+            <a:r>
+              <a:rPr sz="900" b="0">
+                <a:solidFill>
+                  <a:srgbClr val="5B6372"/>
                 </a:solidFill>
                 <a:latin typeface="Arial"/>
               </a:rPr>
@@ -5336,14 +5077,14 @@
       </p:sp>
       <p:sp>
         <p:nvSpPr>
-          <p:cNvPr id="18" name="TextBox 17"/>
+          <p:cNvPr id="12" name="TextBox 11"/>
           <p:cNvSpPr txBox="1"/>
           <p:nvPr/>
         </p:nvSpPr>
         <p:spPr>
           <a:xfrm>
-            <a:off x="1536192" y="3959352"/>
-            <a:ext cx="9710928" cy="329184"/>
+            <a:off x="1554480" y="2157984"/>
+            <a:ext cx="9418320" cy="256032"/>
           </a:xfrm>
           <a:prstGeom prst="rect">
             <a:avLst/>
@@ -5358,27 +5099,27 @@
           <a:p>
             <a:pPr algn="l"/>
             <a:r>
-              <a:rPr sz="1400" b="1">
-                <a:solidFill>
-                  <a:srgbClr val="10B981"/>
+              <a:rPr sz="1050" b="1">
+                <a:solidFill>
+                  <a:srgbClr val="161B26"/>
                 </a:solidFill>
                 <a:latin typeface="Arial"/>
               </a:rPr>
-              <a:t>Decision pressure</a:t>
-            </a:r>
-          </a:p>
-        </p:txBody>
-      </p:sp>
-      <p:sp>
-        <p:nvSpPr>
-          <p:cNvPr id="19" name="TextBox 18"/>
+              <a:t>Sections:</a:t>
+            </a:r>
+          </a:p>
+        </p:txBody>
+      </p:sp>
+      <p:sp>
+        <p:nvSpPr>
+          <p:cNvPr id="13" name="TextBox 12"/>
           <p:cNvSpPr txBox="1"/>
           <p:nvPr/>
         </p:nvSpPr>
         <p:spPr>
           <a:xfrm>
-            <a:off x="1536192" y="4343400"/>
-            <a:ext cx="9710928" cy="978408"/>
+            <a:off x="960120" y="2441448"/>
+            <a:ext cx="384048" cy="246888"/>
           </a:xfrm>
           <a:prstGeom prst="rect">
             <a:avLst/>
@@ -5391,15 +5132,680 @@
           </a:bodyPr>
           <a:lstStyle/>
           <a:p>
-            <a:pPr algn="l"/>
-            <a:r>
-              <a:rPr sz="1150" b="0">
-                <a:solidFill>
-                  <a:srgbClr val="161B26"/>
+            <a:pPr algn="r"/>
+            <a:r>
+              <a:rPr sz="900" b="0">
+                <a:solidFill>
+                  <a:srgbClr val="5B6372"/>
                 </a:solidFill>
                 <a:latin typeface="Arial"/>
               </a:rPr>
-              <a:t>Use an approved AI assistant with the supplied CSV, workbook and source notes to produce a clean analysis and candidate insights. Verify every number in Excel before recommending one next step.</a:t>
+              <a:t>3</a:t>
+            </a:r>
+          </a:p>
+        </p:txBody>
+      </p:sp>
+      <p:sp>
+        <p:nvSpPr>
+          <p:cNvPr id="14" name="TextBox 13"/>
+          <p:cNvSpPr txBox="1"/>
+          <p:nvPr/>
+        </p:nvSpPr>
+        <p:spPr>
+          <a:xfrm>
+            <a:off x="1554480" y="2441448"/>
+            <a:ext cx="9418320" cy="256032"/>
+          </a:xfrm>
+          <a:prstGeom prst="rect">
+            <a:avLst/>
+          </a:prstGeom>
+          <a:noFill/>
+        </p:spPr>
+        <p:txBody>
+          <a:bodyPr wrap="square" anchor="t">
+            <a:spAutoFit/>
+          </a:bodyPr>
+          <a:lstStyle/>
+          <a:p>
+            <a:pPr algn="l"/>
+            <a:r>
+              <a:rPr sz="1050" b="0">
+                <a:solidFill>
+                  <a:srgbClr val="161B26"/>
+                </a:solidFill>
+                <a:latin typeface="Arial"/>
+              </a:rPr>
+              <a:t>1. 78%</a:t>
+            </a:r>
+          </a:p>
+        </p:txBody>
+      </p:sp>
+      <p:sp>
+        <p:nvSpPr>
+          <p:cNvPr id="15" name="TextBox 14"/>
+          <p:cNvSpPr txBox="1"/>
+          <p:nvPr/>
+        </p:nvSpPr>
+        <p:spPr>
+          <a:xfrm>
+            <a:off x="960120" y="2724911"/>
+            <a:ext cx="384048" cy="246888"/>
+          </a:xfrm>
+          <a:prstGeom prst="rect">
+            <a:avLst/>
+          </a:prstGeom>
+          <a:noFill/>
+        </p:spPr>
+        <p:txBody>
+          <a:bodyPr wrap="square" anchor="t">
+            <a:spAutoFit/>
+          </a:bodyPr>
+          <a:lstStyle/>
+          <a:p>
+            <a:pPr algn="r"/>
+            <a:r>
+              <a:rPr sz="900" b="0">
+                <a:solidFill>
+                  <a:srgbClr val="5B6372"/>
+                </a:solidFill>
+                <a:latin typeface="Arial"/>
+              </a:rPr>
+              <a:t>4</a:t>
+            </a:r>
+          </a:p>
+        </p:txBody>
+      </p:sp>
+      <p:sp>
+        <p:nvSpPr>
+          <p:cNvPr id="16" name="TextBox 15"/>
+          <p:cNvSpPr txBox="1"/>
+          <p:nvPr/>
+        </p:nvSpPr>
+        <p:spPr>
+          <a:xfrm>
+            <a:off x="1554480" y="2724911"/>
+            <a:ext cx="9418320" cy="256032"/>
+          </a:xfrm>
+          <a:prstGeom prst="rect">
+            <a:avLst/>
+          </a:prstGeom>
+          <a:noFill/>
+        </p:spPr>
+        <p:txBody>
+          <a:bodyPr wrap="square" anchor="t">
+            <a:spAutoFit/>
+          </a:bodyPr>
+          <a:lstStyle/>
+          <a:p>
+            <a:pPr algn="l"/>
+            <a:r>
+              <a:rPr sz="1050" b="0">
+                <a:solidFill>
+                  <a:srgbClr val="161B26"/>
+                </a:solidFill>
+                <a:latin typeface="Arial"/>
+              </a:rPr>
+              <a:t>2. 86%</a:t>
+            </a:r>
+          </a:p>
+        </p:txBody>
+      </p:sp>
+      <p:sp>
+        <p:nvSpPr>
+          <p:cNvPr id="17" name="TextBox 16"/>
+          <p:cNvSpPr txBox="1"/>
+          <p:nvPr/>
+        </p:nvSpPr>
+        <p:spPr>
+          <a:xfrm>
+            <a:off x="960120" y="3008376"/>
+            <a:ext cx="384048" cy="246888"/>
+          </a:xfrm>
+          <a:prstGeom prst="rect">
+            <a:avLst/>
+          </a:prstGeom>
+          <a:noFill/>
+        </p:spPr>
+        <p:txBody>
+          <a:bodyPr wrap="square" anchor="t">
+            <a:spAutoFit/>
+          </a:bodyPr>
+          <a:lstStyle/>
+          <a:p>
+            <a:pPr algn="r"/>
+            <a:r>
+              <a:rPr sz="900" b="0">
+                <a:solidFill>
+                  <a:srgbClr val="5B6372"/>
+                </a:solidFill>
+                <a:latin typeface="Arial"/>
+              </a:rPr>
+              <a:t>5</a:t>
+            </a:r>
+          </a:p>
+        </p:txBody>
+      </p:sp>
+      <p:sp>
+        <p:nvSpPr>
+          <p:cNvPr id="18" name="TextBox 17"/>
+          <p:cNvSpPr txBox="1"/>
+          <p:nvPr/>
+        </p:nvSpPr>
+        <p:spPr>
+          <a:xfrm>
+            <a:off x="1554480" y="3008376"/>
+            <a:ext cx="9418320" cy="256032"/>
+          </a:xfrm>
+          <a:prstGeom prst="rect">
+            <a:avLst/>
+          </a:prstGeom>
+          <a:noFill/>
+        </p:spPr>
+        <p:txBody>
+          <a:bodyPr wrap="square" anchor="t">
+            <a:spAutoFit/>
+          </a:bodyPr>
+          <a:lstStyle/>
+          <a:p>
+            <a:pPr algn="l"/>
+            <a:r>
+              <a:rPr sz="1050" b="0">
+                <a:solidFill>
+                  <a:srgbClr val="161B26"/>
+                </a:solidFill>
+                <a:latin typeface="Arial"/>
+              </a:rPr>
+              <a:t>3. 69%</a:t>
+            </a:r>
+          </a:p>
+        </p:txBody>
+      </p:sp>
+      <p:sp>
+        <p:nvSpPr>
+          <p:cNvPr id="19" name="TextBox 18"/>
+          <p:cNvSpPr txBox="1"/>
+          <p:nvPr/>
+        </p:nvSpPr>
+        <p:spPr>
+          <a:xfrm>
+            <a:off x="960120" y="3291839"/>
+            <a:ext cx="384048" cy="246888"/>
+          </a:xfrm>
+          <a:prstGeom prst="rect">
+            <a:avLst/>
+          </a:prstGeom>
+          <a:noFill/>
+        </p:spPr>
+        <p:txBody>
+          <a:bodyPr wrap="square" anchor="t">
+            <a:spAutoFit/>
+          </a:bodyPr>
+          <a:lstStyle/>
+          <a:p>
+            <a:pPr algn="r"/>
+            <a:r>
+              <a:rPr sz="900" b="0">
+                <a:solidFill>
+                  <a:srgbClr val="5B6372"/>
+                </a:solidFill>
+                <a:latin typeface="Arial"/>
+              </a:rPr>
+              <a:t>6</a:t>
+            </a:r>
+          </a:p>
+        </p:txBody>
+      </p:sp>
+      <p:sp>
+        <p:nvSpPr>
+          <p:cNvPr id="20" name="TextBox 19"/>
+          <p:cNvSpPr txBox="1"/>
+          <p:nvPr/>
+        </p:nvSpPr>
+        <p:spPr>
+          <a:xfrm>
+            <a:off x="1554480" y="3291839"/>
+            <a:ext cx="9418320" cy="256032"/>
+          </a:xfrm>
+          <a:prstGeom prst="rect">
+            <a:avLst/>
+          </a:prstGeom>
+          <a:noFill/>
+        </p:spPr>
+        <p:txBody>
+          <a:bodyPr wrap="square" anchor="t">
+            <a:spAutoFit/>
+          </a:bodyPr>
+          <a:lstStyle/>
+          <a:p>
+            <a:pPr algn="l"/>
+            <a:r>
+              <a:rPr sz="1050" b="0">
+                <a:solidFill>
+                  <a:srgbClr val="161B26"/>
+                </a:solidFill>
+                <a:latin typeface="Arial"/>
+              </a:rPr>
+              <a:t>4. +11 pts</a:t>
+            </a:r>
+          </a:p>
+        </p:txBody>
+      </p:sp>
+      <p:sp>
+        <p:nvSpPr>
+          <p:cNvPr id="21" name="TextBox 20"/>
+          <p:cNvSpPr txBox="1"/>
+          <p:nvPr/>
+        </p:nvSpPr>
+        <p:spPr>
+          <a:xfrm>
+            <a:off x="960120" y="3575303"/>
+            <a:ext cx="384048" cy="246888"/>
+          </a:xfrm>
+          <a:prstGeom prst="rect">
+            <a:avLst/>
+          </a:prstGeom>
+          <a:noFill/>
+        </p:spPr>
+        <p:txBody>
+          <a:bodyPr wrap="square" anchor="t">
+            <a:spAutoFit/>
+          </a:bodyPr>
+          <a:lstStyle/>
+          <a:p>
+            <a:pPr algn="r"/>
+            <a:r>
+              <a:rPr sz="900" b="0">
+                <a:solidFill>
+                  <a:srgbClr val="5B6372"/>
+                </a:solidFill>
+                <a:latin typeface="Arial"/>
+              </a:rPr>
+              <a:t>7</a:t>
+            </a:r>
+          </a:p>
+        </p:txBody>
+      </p:sp>
+      <p:sp>
+        <p:nvSpPr>
+          <p:cNvPr id="22" name="TextBox 21"/>
+          <p:cNvSpPr txBox="1"/>
+          <p:nvPr/>
+        </p:nvSpPr>
+        <p:spPr>
+          <a:xfrm>
+            <a:off x="1554480" y="3575303"/>
+            <a:ext cx="9418320" cy="256032"/>
+          </a:xfrm>
+          <a:prstGeom prst="rect">
+            <a:avLst/>
+          </a:prstGeom>
+          <a:noFill/>
+        </p:spPr>
+        <p:txBody>
+          <a:bodyPr wrap="square" anchor="t">
+            <a:spAutoFit/>
+          </a:bodyPr>
+          <a:lstStyle/>
+          <a:p>
+            <a:pPr algn="l"/>
+            <a:r>
+              <a:rPr sz="1050" b="0">
+                <a:solidFill>
+                  <a:srgbClr val="161B26"/>
+                </a:solidFill>
+                <a:latin typeface="Arial"/>
+              </a:rPr>
+              <a:t>5. 420</a:t>
+            </a:r>
+          </a:p>
+        </p:txBody>
+      </p:sp>
+      <p:sp>
+        <p:nvSpPr>
+          <p:cNvPr id="23" name="TextBox 22"/>
+          <p:cNvSpPr txBox="1"/>
+          <p:nvPr/>
+        </p:nvSpPr>
+        <p:spPr>
+          <a:xfrm>
+            <a:off x="960120" y="3858768"/>
+            <a:ext cx="384048" cy="246888"/>
+          </a:xfrm>
+          <a:prstGeom prst="rect">
+            <a:avLst/>
+          </a:prstGeom>
+          <a:noFill/>
+        </p:spPr>
+        <p:txBody>
+          <a:bodyPr wrap="square" anchor="t">
+            <a:spAutoFit/>
+          </a:bodyPr>
+          <a:lstStyle/>
+          <a:p>
+            <a:pPr algn="r"/>
+            <a:r>
+              <a:rPr sz="900" b="0">
+                <a:solidFill>
+                  <a:srgbClr val="5B6372"/>
+                </a:solidFill>
+                <a:latin typeface="Arial"/>
+              </a:rPr>
+              <a:t>8</a:t>
+            </a:r>
+          </a:p>
+        </p:txBody>
+      </p:sp>
+      <p:sp>
+        <p:nvSpPr>
+          <p:cNvPr id="24" name="TextBox 23"/>
+          <p:cNvSpPr txBox="1"/>
+          <p:nvPr/>
+        </p:nvSpPr>
+        <p:spPr>
+          <a:xfrm>
+            <a:off x="1554480" y="3858768"/>
+            <a:ext cx="9418320" cy="256032"/>
+          </a:xfrm>
+          <a:prstGeom prst="rect">
+            <a:avLst/>
+          </a:prstGeom>
+          <a:noFill/>
+        </p:spPr>
+        <p:txBody>
+          <a:bodyPr wrap="square" anchor="t">
+            <a:spAutoFit/>
+          </a:bodyPr>
+          <a:lstStyle/>
+          <a:p>
+            <a:pPr algn="l"/>
+            <a:r>
+              <a:rPr sz="1050" b="0">
+                <a:solidFill>
+                  <a:srgbClr val="7C3AED"/>
+                </a:solidFill>
+                <a:latin typeface="Arial"/>
+              </a:rPr>
+              <a:t>Audience: retail management team</a:t>
+            </a:r>
+          </a:p>
+        </p:txBody>
+      </p:sp>
+      <p:sp>
+        <p:nvSpPr>
+          <p:cNvPr id="25" name="TextBox 24"/>
+          <p:cNvSpPr txBox="1"/>
+          <p:nvPr/>
+        </p:nvSpPr>
+        <p:spPr>
+          <a:xfrm>
+            <a:off x="960120" y="4142231"/>
+            <a:ext cx="384048" cy="246888"/>
+          </a:xfrm>
+          <a:prstGeom prst="rect">
+            <a:avLst/>
+          </a:prstGeom>
+          <a:noFill/>
+        </p:spPr>
+        <p:txBody>
+          <a:bodyPr wrap="square" anchor="t">
+            <a:spAutoFit/>
+          </a:bodyPr>
+          <a:lstStyle/>
+          <a:p>
+            <a:pPr algn="r"/>
+            <a:r>
+              <a:rPr sz="900" b="0">
+                <a:solidFill>
+                  <a:srgbClr val="5B6372"/>
+                </a:solidFill>
+                <a:latin typeface="Arial"/>
+              </a:rPr>
+              <a:t>9</a:t>
+            </a:r>
+          </a:p>
+        </p:txBody>
+      </p:sp>
+      <p:sp>
+        <p:nvSpPr>
+          <p:cNvPr id="26" name="TextBox 25"/>
+          <p:cNvSpPr txBox="1"/>
+          <p:nvPr/>
+        </p:nvSpPr>
+        <p:spPr>
+          <a:xfrm>
+            <a:off x="1554480" y="4142231"/>
+            <a:ext cx="9418320" cy="256032"/>
+          </a:xfrm>
+          <a:prstGeom prst="rect">
+            <a:avLst/>
+          </a:prstGeom>
+          <a:noFill/>
+        </p:spPr>
+        <p:txBody>
+          <a:bodyPr wrap="square" anchor="t">
+            <a:spAutoFit/>
+          </a:bodyPr>
+          <a:lstStyle/>
+          <a:p>
+            <a:pPr algn="l"/>
+            <a:r>
+              <a:rPr sz="1050" b="0">
+                <a:solidFill>
+                  <a:srgbClr val="7C3AED"/>
+                </a:solidFill>
+                <a:latin typeface="Arial"/>
+              </a:rPr>
+              <a:t>Decision: The final insight clearly separates what the data shows, what it may mean, why it matters and what should happen next.</a:t>
+            </a:r>
+          </a:p>
+        </p:txBody>
+      </p:sp>
+      <p:sp>
+        <p:nvSpPr>
+          <p:cNvPr id="27" name="TextBox 26"/>
+          <p:cNvSpPr txBox="1"/>
+          <p:nvPr/>
+        </p:nvSpPr>
+        <p:spPr>
+          <a:xfrm>
+            <a:off x="960120" y="4425696"/>
+            <a:ext cx="384048" cy="246888"/>
+          </a:xfrm>
+          <a:prstGeom prst="rect">
+            <a:avLst/>
+          </a:prstGeom>
+          <a:noFill/>
+        </p:spPr>
+        <p:txBody>
+          <a:bodyPr wrap="square" anchor="t">
+            <a:spAutoFit/>
+          </a:bodyPr>
+          <a:lstStyle/>
+          <a:p>
+            <a:pPr algn="r"/>
+            <a:r>
+              <a:rPr sz="900" b="0">
+                <a:solidFill>
+                  <a:srgbClr val="5B6372"/>
+                </a:solidFill>
+                <a:latin typeface="Arial"/>
+              </a:rPr>
+              <a:t>10</a:t>
+            </a:r>
+          </a:p>
+        </p:txBody>
+      </p:sp>
+      <p:sp>
+        <p:nvSpPr>
+          <p:cNvPr id="28" name="TextBox 27"/>
+          <p:cNvSpPr txBox="1"/>
+          <p:nvPr/>
+        </p:nvSpPr>
+        <p:spPr>
+          <a:xfrm>
+            <a:off x="1554480" y="4425696"/>
+            <a:ext cx="9418320" cy="256032"/>
+          </a:xfrm>
+          <a:prstGeom prst="rect">
+            <a:avLst/>
+          </a:prstGeom>
+          <a:noFill/>
+        </p:spPr>
+        <p:txBody>
+          <a:bodyPr wrap="square" anchor="t">
+            <a:spAutoFit/>
+          </a:bodyPr>
+          <a:lstStyle/>
+          <a:p>
+            <a:pPr algn="l"/>
+            <a:r>
+              <a:rPr sz="1050" b="0">
+                <a:solidFill>
+                  <a:srgbClr val="7C3AED"/>
+                </a:solidFill>
+                <a:latin typeface="Arial"/>
+              </a:rPr>
+              <a:t>Style: professional, concise, high contrast and accessible</a:t>
+            </a:r>
+          </a:p>
+        </p:txBody>
+      </p:sp>
+      <p:sp>
+        <p:nvSpPr>
+          <p:cNvPr id="29" name="TextBox 28"/>
+          <p:cNvSpPr txBox="1"/>
+          <p:nvPr/>
+        </p:nvSpPr>
+        <p:spPr>
+          <a:xfrm>
+            <a:off x="960120" y="4709160"/>
+            <a:ext cx="384048" cy="246888"/>
+          </a:xfrm>
+          <a:prstGeom prst="rect">
+            <a:avLst/>
+          </a:prstGeom>
+          <a:noFill/>
+        </p:spPr>
+        <p:txBody>
+          <a:bodyPr wrap="square" anchor="t">
+            <a:spAutoFit/>
+          </a:bodyPr>
+          <a:lstStyle/>
+          <a:p>
+            <a:pPr algn="r"/>
+            <a:r>
+              <a:rPr sz="900" b="0">
+                <a:solidFill>
+                  <a:srgbClr val="5B6372"/>
+                </a:solidFill>
+                <a:latin typeface="Arial"/>
+              </a:rPr>
+              <a:t>11</a:t>
+            </a:r>
+          </a:p>
+        </p:txBody>
+      </p:sp>
+      <p:sp>
+        <p:nvSpPr>
+          <p:cNvPr id="30" name="TextBox 29"/>
+          <p:cNvSpPr txBox="1"/>
+          <p:nvPr/>
+        </p:nvSpPr>
+        <p:spPr>
+          <a:xfrm>
+            <a:off x="1554480" y="4709160"/>
+            <a:ext cx="9418320" cy="256032"/>
+          </a:xfrm>
+          <a:prstGeom prst="rect">
+            <a:avLst/>
+          </a:prstGeom>
+          <a:noFill/>
+        </p:spPr>
+        <p:txBody>
+          <a:bodyPr wrap="square" anchor="t">
+            <a:spAutoFit/>
+          </a:bodyPr>
+          <a:lstStyle/>
+          <a:p>
+            <a:pPr algn="l"/>
+            <a:r>
+              <a:rPr sz="1050" b="0">
+                <a:solidFill>
+                  <a:srgbClr val="7C3AED"/>
+                </a:solidFill>
+                <a:latin typeface="Arial"/>
+              </a:rPr>
+              <a:t>Format: Wide for PowerPoint unless the brief requires Portrait</a:t>
+            </a:r>
+          </a:p>
+        </p:txBody>
+      </p:sp>
+      <p:sp>
+        <p:nvSpPr>
+          <p:cNvPr id="31" name="TextBox 30"/>
+          <p:cNvSpPr txBox="1"/>
+          <p:nvPr/>
+        </p:nvSpPr>
+        <p:spPr>
+          <a:xfrm>
+            <a:off x="960120" y="4992624"/>
+            <a:ext cx="384048" cy="246888"/>
+          </a:xfrm>
+          <a:prstGeom prst="rect">
+            <a:avLst/>
+          </a:prstGeom>
+          <a:noFill/>
+        </p:spPr>
+        <p:txBody>
+          <a:bodyPr wrap="square" anchor="t">
+            <a:spAutoFit/>
+          </a:bodyPr>
+          <a:lstStyle/>
+          <a:p>
+            <a:pPr algn="r"/>
+            <a:r>
+              <a:rPr sz="900" b="0">
+                <a:solidFill>
+                  <a:srgbClr val="5B6372"/>
+                </a:solidFill>
+                <a:latin typeface="Arial"/>
+              </a:rPr>
+              <a:t>12</a:t>
+            </a:r>
+          </a:p>
+        </p:txBody>
+      </p:sp>
+      <p:sp>
+        <p:nvSpPr>
+          <p:cNvPr id="32" name="TextBox 31"/>
+          <p:cNvSpPr txBox="1"/>
+          <p:nvPr/>
+        </p:nvSpPr>
+        <p:spPr>
+          <a:xfrm>
+            <a:off x="1554480" y="4992624"/>
+            <a:ext cx="9418320" cy="256032"/>
+          </a:xfrm>
+          <a:prstGeom prst="rect">
+            <a:avLst/>
+          </a:prstGeom>
+          <a:noFill/>
+        </p:spPr>
+        <p:txBody>
+          <a:bodyPr wrap="square" anchor="t">
+            <a:spAutoFit/>
+          </a:bodyPr>
+          <a:lstStyle/>
+          <a:p>
+            <a:pPr algn="l"/>
+            <a:r>
+              <a:rPr sz="1050" b="0">
+                <a:solidFill>
+                  <a:srgbClr val="7C3AED"/>
+                </a:solidFill>
+                <a:latin typeface="Arial"/>
+              </a:rPr>
+              <a:t>Source rule: use only the attached approved or synthetic course data; include period and source; do not invent facts</a:t>
             </a:r>
           </a:p>
         </p:txBody>
@@ -5482,11 +5888,11 @@
             <a:avLst/>
           </a:prstGeom>
           <a:solidFill>
-            <a:srgbClr val="10B981"/>
+            <a:srgbClr val="1F6FEB"/>
           </a:solidFill>
           <a:ln>
             <a:solidFill>
-              <a:srgbClr val="10B981"/>
+              <a:srgbClr val="1F6FEB"/>
             </a:solidFill>
           </a:ln>
         </p:spPr>
@@ -5538,11 +5944,11 @@
             <a:r>
               <a:rPr sz="1100" b="1">
                 <a:solidFill>
-                  <a:srgbClr val="10B981"/>
+                  <a:srgbClr val="1F6FEB"/>
                 </a:solidFill>
                 <a:latin typeface="Arial"/>
               </a:rPr>
-              <a:t>ACTIVITY 01 · FRAMEWORK</a:t>
+              <a:t>ACTIVITY 01 · CONTEXT</a:t>
             </a:r>
           </a:p>
         </p:txBody>
@@ -5577,7 +5983,7 @@
                 </a:solidFill>
                 <a:latin typeface="Arial"/>
               </a:rPr>
-              <a:t>Collect, Clean, Analyse, Verify</a:t>
+              <a:t>The Scenario</a:t>
             </a:r>
           </a:p>
         </p:txBody>
@@ -5670,8 +6076,8 @@
         </p:nvSpPr>
         <p:spPr>
           <a:xfrm>
-            <a:off x="685800" y="1920240"/>
-            <a:ext cx="1997049" cy="3566160"/>
+            <a:off x="731520" y="1783080"/>
+            <a:ext cx="10698480" cy="1691640"/>
           </a:xfrm>
           <a:prstGeom prst="roundRect">
             <a:avLst/>
@@ -5715,8 +6121,8 @@
         </p:nvSpPr>
         <p:spPr>
           <a:xfrm>
-            <a:off x="685800" y="1920240"/>
-            <a:ext cx="73152" cy="3566160"/>
+            <a:off x="731520" y="1783080"/>
+            <a:ext cx="73152" cy="1691640"/>
           </a:xfrm>
           <a:prstGeom prst="rect">
             <a:avLst/>
@@ -5760,7 +6166,7 @@
         </p:nvSpPr>
         <p:spPr>
           <a:xfrm>
-            <a:off x="886968" y="2139696"/>
+            <a:off x="932688" y="2002536"/>
             <a:ext cx="438912" cy="438912"/>
           </a:xfrm>
           <a:prstGeom prst="roundRect">
@@ -5805,7 +6211,7 @@
         </p:nvSpPr>
         <p:spPr>
           <a:xfrm>
-            <a:off x="886968" y="2148840"/>
+            <a:off x="932688" y="2011680"/>
             <a:ext cx="438912" cy="420624"/>
           </a:xfrm>
           <a:prstGeom prst="rect">
@@ -5840,8 +6246,8 @@
         </p:nvSpPr>
         <p:spPr>
           <a:xfrm>
-            <a:off x="1490472" y="2103120"/>
-            <a:ext cx="1009497" cy="329184"/>
+            <a:off x="1536192" y="1965960"/>
+            <a:ext cx="9710928" cy="329184"/>
           </a:xfrm>
           <a:prstGeom prst="rect">
             <a:avLst/>
@@ -5862,7 +6268,7 @@
                 </a:solidFill>
                 <a:latin typeface="Arial"/>
               </a:rPr>
-              <a:t>Collect</a:t>
+              <a:t>Context</a:t>
             </a:r>
           </a:p>
         </p:txBody>
@@ -5875,8 +6281,8 @@
         </p:nvSpPr>
         <p:spPr>
           <a:xfrm>
-            <a:off x="1490472" y="2487168"/>
-            <a:ext cx="1009497" cy="2852928"/>
+            <a:off x="1536192" y="2350008"/>
+            <a:ext cx="9710928" cy="978408"/>
           </a:xfrm>
           <a:prstGeom prst="rect">
             <a:avLst/>
@@ -5897,7 +6303,7 @@
                 </a:solidFill>
                 <a:latin typeface="Arial"/>
               </a:rPr>
-              <a:t>Register the approved CSV, workbook and research notes.</a:t>
+              <a:t>Northstar Retail's marketing lead has a one-page customer survey infographic built from 420 synthetic Q2 responses. Leadership wants to know which customer experience deserves further investigation.</a:t>
             </a:r>
           </a:p>
         </p:txBody>
@@ -5910,8 +6316,8 @@
         </p:nvSpPr>
         <p:spPr>
           <a:xfrm>
-            <a:off x="2884017" y="1920240"/>
-            <a:ext cx="1997049" cy="3566160"/>
+            <a:off x="731520" y="3776472"/>
+            <a:ext cx="10698480" cy="1691640"/>
           </a:xfrm>
           <a:prstGeom prst="roundRect">
             <a:avLst/>
@@ -5955,8 +6361,8 @@
         </p:nvSpPr>
         <p:spPr>
           <a:xfrm>
-            <a:off x="2884017" y="1920240"/>
-            <a:ext cx="73152" cy="3566160"/>
+            <a:off x="731520" y="3776472"/>
+            <a:ext cx="73152" cy="1691640"/>
           </a:xfrm>
           <a:prstGeom prst="rect">
             <a:avLst/>
@@ -6000,7 +6406,7 @@
         </p:nvSpPr>
         <p:spPr>
           <a:xfrm>
-            <a:off x="3085185" y="2139696"/>
+            <a:off x="932688" y="3995928"/>
             <a:ext cx="438912" cy="438912"/>
           </a:xfrm>
           <a:prstGeom prst="roundRect">
@@ -6045,7 +6451,7 @@
         </p:nvSpPr>
         <p:spPr>
           <a:xfrm>
-            <a:off x="3085185" y="2148840"/>
+            <a:off x="932688" y="4005072"/>
             <a:ext cx="438912" cy="420624"/>
           </a:xfrm>
           <a:prstGeom prst="rect">
@@ -6080,8 +6486,8 @@
         </p:nvSpPr>
         <p:spPr>
           <a:xfrm>
-            <a:off x="3688689" y="2103120"/>
-            <a:ext cx="1009497" cy="329184"/>
+            <a:off x="1536192" y="3959352"/>
+            <a:ext cx="9710928" cy="329184"/>
           </a:xfrm>
           <a:prstGeom prst="rect">
             <a:avLst/>
@@ -6102,7 +6508,7 @@
                 </a:solidFill>
                 <a:latin typeface="Arial"/>
               </a:rPr>
-              <a:t>Clean</a:t>
+              <a:t>Decision pressure</a:t>
             </a:r>
           </a:p>
         </p:txBody>
@@ -6115,8 +6521,8 @@
         </p:nvSpPr>
         <p:spPr>
           <a:xfrm>
-            <a:off x="3688689" y="2487168"/>
-            <a:ext cx="1009497" cy="2852928"/>
+            <a:off x="1536192" y="4343400"/>
+            <a:ext cx="9710928" cy="978408"/>
           </a:xfrm>
           <a:prstGeom prst="rect">
             <a:avLst/>
@@ -6137,727 +6543,7 @@
                 </a:solidFill>
                 <a:latin typeface="Arial"/>
               </a:rPr>
-              <a:t>Standardise labels, units and missing-value handling without changing raw evidence.</a:t>
-            </a:r>
-          </a:p>
-        </p:txBody>
-      </p:sp>
-      <p:sp>
-        <p:nvSpPr>
-          <p:cNvPr id="20" name="Rounded Rectangle 19"/>
-          <p:cNvSpPr/>
-          <p:nvPr/>
-        </p:nvSpPr>
-        <p:spPr>
-          <a:xfrm>
-            <a:off x="5082235" y="1920240"/>
-            <a:ext cx="1997049" cy="3566160"/>
-          </a:xfrm>
-          <a:prstGeom prst="roundRect">
-            <a:avLst/>
-          </a:prstGeom>
-          <a:solidFill>
-            <a:srgbClr val="F5F8FC"/>
-          </a:solidFill>
-          <a:ln>
-            <a:solidFill>
-              <a:srgbClr val="E2E8F0"/>
-            </a:solidFill>
-          </a:ln>
-        </p:spPr>
-        <p:style>
-          <a:lnRef idx="1">
-            <a:schemeClr val="accent1"/>
-          </a:lnRef>
-          <a:fillRef idx="3">
-            <a:schemeClr val="accent1"/>
-          </a:fillRef>
-          <a:effectRef idx="2">
-            <a:schemeClr val="accent1"/>
-          </a:effectRef>
-          <a:fontRef idx="minor">
-            <a:schemeClr val="lt1"/>
-          </a:fontRef>
-        </p:style>
-        <p:txBody>
-          <a:bodyPr rtlCol="0" anchor="ctr"/>
-          <a:lstStyle/>
-          <a:p>
-            <a:pPr algn="ctr"/>
-          </a:p>
-        </p:txBody>
-      </p:sp>
-      <p:sp>
-        <p:nvSpPr>
-          <p:cNvPr id="21" name="Rectangle 20"/>
-          <p:cNvSpPr/>
-          <p:nvPr/>
-        </p:nvSpPr>
-        <p:spPr>
-          <a:xfrm>
-            <a:off x="5082235" y="1920240"/>
-            <a:ext cx="73152" cy="3566160"/>
-          </a:xfrm>
-          <a:prstGeom prst="rect">
-            <a:avLst/>
-          </a:prstGeom>
-          <a:solidFill>
-            <a:srgbClr val="7C3AED"/>
-          </a:solidFill>
-          <a:ln>
-            <a:solidFill>
-              <a:srgbClr val="7C3AED"/>
-            </a:solidFill>
-          </a:ln>
-        </p:spPr>
-        <p:style>
-          <a:lnRef idx="1">
-            <a:schemeClr val="accent1"/>
-          </a:lnRef>
-          <a:fillRef idx="3">
-            <a:schemeClr val="accent1"/>
-          </a:fillRef>
-          <a:effectRef idx="2">
-            <a:schemeClr val="accent1"/>
-          </a:effectRef>
-          <a:fontRef idx="minor">
-            <a:schemeClr val="lt1"/>
-          </a:fontRef>
-        </p:style>
-        <p:txBody>
-          <a:bodyPr rtlCol="0" anchor="ctr"/>
-          <a:lstStyle/>
-          <a:p>
-            <a:pPr algn="ctr"/>
-          </a:p>
-        </p:txBody>
-      </p:sp>
-      <p:sp>
-        <p:nvSpPr>
-          <p:cNvPr id="22" name="Rounded Rectangle 21"/>
-          <p:cNvSpPr/>
-          <p:nvPr/>
-        </p:nvSpPr>
-        <p:spPr>
-          <a:xfrm>
-            <a:off x="5283403" y="2139696"/>
-            <a:ext cx="438912" cy="438912"/>
-          </a:xfrm>
-          <a:prstGeom prst="roundRect">
-            <a:avLst/>
-          </a:prstGeom>
-          <a:solidFill>
-            <a:srgbClr val="7C3AED"/>
-          </a:solidFill>
-          <a:ln>
-            <a:solidFill>
-              <a:srgbClr val="7C3AED"/>
-            </a:solidFill>
-          </a:ln>
-        </p:spPr>
-        <p:style>
-          <a:lnRef idx="1">
-            <a:schemeClr val="accent1"/>
-          </a:lnRef>
-          <a:fillRef idx="3">
-            <a:schemeClr val="accent1"/>
-          </a:fillRef>
-          <a:effectRef idx="2">
-            <a:schemeClr val="accent1"/>
-          </a:effectRef>
-          <a:fontRef idx="minor">
-            <a:schemeClr val="lt1"/>
-          </a:fontRef>
-        </p:style>
-        <p:txBody>
-          <a:bodyPr rtlCol="0" anchor="ctr"/>
-          <a:lstStyle/>
-          <a:p>
-            <a:pPr algn="ctr"/>
-          </a:p>
-        </p:txBody>
-      </p:sp>
-      <p:sp>
-        <p:nvSpPr>
-          <p:cNvPr id="23" name="TextBox 22"/>
-          <p:cNvSpPr txBox="1"/>
-          <p:nvPr/>
-        </p:nvSpPr>
-        <p:spPr>
-          <a:xfrm>
-            <a:off x="5283403" y="2148840"/>
-            <a:ext cx="438912" cy="420624"/>
-          </a:xfrm>
-          <a:prstGeom prst="rect">
-            <a:avLst/>
-          </a:prstGeom>
-          <a:noFill/>
-        </p:spPr>
-        <p:txBody>
-          <a:bodyPr wrap="square" anchor="ctr">
-            <a:spAutoFit/>
-          </a:bodyPr>
-          <a:lstStyle/>
-          <a:p>
-            <a:pPr algn="ctr"/>
-            <a:r>
-              <a:rPr sz="1400" b="1">
-                <a:solidFill>
-                  <a:srgbClr val="FFFFFF"/>
-                </a:solidFill>
-                <a:latin typeface="Arial"/>
-              </a:rPr>
-              <a:t>3</a:t>
-            </a:r>
-          </a:p>
-        </p:txBody>
-      </p:sp>
-      <p:sp>
-        <p:nvSpPr>
-          <p:cNvPr id="24" name="TextBox 23"/>
-          <p:cNvSpPr txBox="1"/>
-          <p:nvPr/>
-        </p:nvSpPr>
-        <p:spPr>
-          <a:xfrm>
-            <a:off x="5886907" y="2103120"/>
-            <a:ext cx="1009497" cy="329184"/>
-          </a:xfrm>
-          <a:prstGeom prst="rect">
-            <a:avLst/>
-          </a:prstGeom>
-          <a:noFill/>
-        </p:spPr>
-        <p:txBody>
-          <a:bodyPr wrap="square" anchor="t">
-            <a:spAutoFit/>
-          </a:bodyPr>
-          <a:lstStyle/>
-          <a:p>
-            <a:pPr algn="l"/>
-            <a:r>
-              <a:rPr sz="1400" b="1">
-                <a:solidFill>
-                  <a:srgbClr val="7C3AED"/>
-                </a:solidFill>
-                <a:latin typeface="Arial"/>
-              </a:rPr>
-              <a:t>Analyse</a:t>
-            </a:r>
-          </a:p>
-        </p:txBody>
-      </p:sp>
-      <p:sp>
-        <p:nvSpPr>
-          <p:cNvPr id="25" name="TextBox 24"/>
-          <p:cNvSpPr txBox="1"/>
-          <p:nvPr/>
-        </p:nvSpPr>
-        <p:spPr>
-          <a:xfrm>
-            <a:off x="5886907" y="2487168"/>
-            <a:ext cx="1009497" cy="2852928"/>
-          </a:xfrm>
-          <a:prstGeom prst="rect">
-            <a:avLst/>
-          </a:prstGeom>
-          <a:noFill/>
-        </p:spPr>
-        <p:txBody>
-          <a:bodyPr wrap="square" anchor="t">
-            <a:spAutoFit/>
-          </a:bodyPr>
-          <a:lstStyle/>
-          <a:p>
-            <a:pPr algn="l"/>
-            <a:r>
-              <a:rPr sz="1150" b="0">
-                <a:solidFill>
-                  <a:srgbClr val="161B26"/>
-                </a:solidFill>
-                <a:latin typeface="Arial"/>
-              </a:rPr>
-              <a:t>Prompt AI for patterns, exceptions and competing explanations.</a:t>
-            </a:r>
-          </a:p>
-        </p:txBody>
-      </p:sp>
-      <p:sp>
-        <p:nvSpPr>
-          <p:cNvPr id="26" name="Rounded Rectangle 25"/>
-          <p:cNvSpPr/>
-          <p:nvPr/>
-        </p:nvSpPr>
-        <p:spPr>
-          <a:xfrm>
-            <a:off x="7280452" y="1920240"/>
-            <a:ext cx="1997049" cy="3566160"/>
-          </a:xfrm>
-          <a:prstGeom prst="roundRect">
-            <a:avLst/>
-          </a:prstGeom>
-          <a:solidFill>
-            <a:srgbClr val="F5F8FC"/>
-          </a:solidFill>
-          <a:ln>
-            <a:solidFill>
-              <a:srgbClr val="E2E8F0"/>
-            </a:solidFill>
-          </a:ln>
-        </p:spPr>
-        <p:style>
-          <a:lnRef idx="1">
-            <a:schemeClr val="accent1"/>
-          </a:lnRef>
-          <a:fillRef idx="3">
-            <a:schemeClr val="accent1"/>
-          </a:fillRef>
-          <a:effectRef idx="2">
-            <a:schemeClr val="accent1"/>
-          </a:effectRef>
-          <a:fontRef idx="minor">
-            <a:schemeClr val="lt1"/>
-          </a:fontRef>
-        </p:style>
-        <p:txBody>
-          <a:bodyPr rtlCol="0" anchor="ctr"/>
-          <a:lstStyle/>
-          <a:p>
-            <a:pPr algn="ctr"/>
-          </a:p>
-        </p:txBody>
-      </p:sp>
-      <p:sp>
-        <p:nvSpPr>
-          <p:cNvPr id="27" name="Rectangle 26"/>
-          <p:cNvSpPr/>
-          <p:nvPr/>
-        </p:nvSpPr>
-        <p:spPr>
-          <a:xfrm>
-            <a:off x="7280452" y="1920240"/>
-            <a:ext cx="73152" cy="3566160"/>
-          </a:xfrm>
-          <a:prstGeom prst="rect">
-            <a:avLst/>
-          </a:prstGeom>
-          <a:solidFill>
-            <a:srgbClr val="F59E0B"/>
-          </a:solidFill>
-          <a:ln>
-            <a:solidFill>
-              <a:srgbClr val="F59E0B"/>
-            </a:solidFill>
-          </a:ln>
-        </p:spPr>
-        <p:style>
-          <a:lnRef idx="1">
-            <a:schemeClr val="accent1"/>
-          </a:lnRef>
-          <a:fillRef idx="3">
-            <a:schemeClr val="accent1"/>
-          </a:fillRef>
-          <a:effectRef idx="2">
-            <a:schemeClr val="accent1"/>
-          </a:effectRef>
-          <a:fontRef idx="minor">
-            <a:schemeClr val="lt1"/>
-          </a:fontRef>
-        </p:style>
-        <p:txBody>
-          <a:bodyPr rtlCol="0" anchor="ctr"/>
-          <a:lstStyle/>
-          <a:p>
-            <a:pPr algn="ctr"/>
-          </a:p>
-        </p:txBody>
-      </p:sp>
-      <p:sp>
-        <p:nvSpPr>
-          <p:cNvPr id="28" name="Rounded Rectangle 27"/>
-          <p:cNvSpPr/>
-          <p:nvPr/>
-        </p:nvSpPr>
-        <p:spPr>
-          <a:xfrm>
-            <a:off x="7481620" y="2139696"/>
-            <a:ext cx="438912" cy="438912"/>
-          </a:xfrm>
-          <a:prstGeom prst="roundRect">
-            <a:avLst/>
-          </a:prstGeom>
-          <a:solidFill>
-            <a:srgbClr val="F59E0B"/>
-          </a:solidFill>
-          <a:ln>
-            <a:solidFill>
-              <a:srgbClr val="F59E0B"/>
-            </a:solidFill>
-          </a:ln>
-        </p:spPr>
-        <p:style>
-          <a:lnRef idx="1">
-            <a:schemeClr val="accent1"/>
-          </a:lnRef>
-          <a:fillRef idx="3">
-            <a:schemeClr val="accent1"/>
-          </a:fillRef>
-          <a:effectRef idx="2">
-            <a:schemeClr val="accent1"/>
-          </a:effectRef>
-          <a:fontRef idx="minor">
-            <a:schemeClr val="lt1"/>
-          </a:fontRef>
-        </p:style>
-        <p:txBody>
-          <a:bodyPr rtlCol="0" anchor="ctr"/>
-          <a:lstStyle/>
-          <a:p>
-            <a:pPr algn="ctr"/>
-          </a:p>
-        </p:txBody>
-      </p:sp>
-      <p:sp>
-        <p:nvSpPr>
-          <p:cNvPr id="29" name="TextBox 28"/>
-          <p:cNvSpPr txBox="1"/>
-          <p:nvPr/>
-        </p:nvSpPr>
-        <p:spPr>
-          <a:xfrm>
-            <a:off x="7481620" y="2148840"/>
-            <a:ext cx="438912" cy="420624"/>
-          </a:xfrm>
-          <a:prstGeom prst="rect">
-            <a:avLst/>
-          </a:prstGeom>
-          <a:noFill/>
-        </p:spPr>
-        <p:txBody>
-          <a:bodyPr wrap="square" anchor="ctr">
-            <a:spAutoFit/>
-          </a:bodyPr>
-          <a:lstStyle/>
-          <a:p>
-            <a:pPr algn="ctr"/>
-            <a:r>
-              <a:rPr sz="1400" b="1">
-                <a:solidFill>
-                  <a:srgbClr val="FFFFFF"/>
-                </a:solidFill>
-                <a:latin typeface="Arial"/>
-              </a:rPr>
-              <a:t>4</a:t>
-            </a:r>
-          </a:p>
-        </p:txBody>
-      </p:sp>
-      <p:sp>
-        <p:nvSpPr>
-          <p:cNvPr id="30" name="TextBox 29"/>
-          <p:cNvSpPr txBox="1"/>
-          <p:nvPr/>
-        </p:nvSpPr>
-        <p:spPr>
-          <a:xfrm>
-            <a:off x="8085124" y="2103120"/>
-            <a:ext cx="1009497" cy="329184"/>
-          </a:xfrm>
-          <a:prstGeom prst="rect">
-            <a:avLst/>
-          </a:prstGeom>
-          <a:noFill/>
-        </p:spPr>
-        <p:txBody>
-          <a:bodyPr wrap="square" anchor="t">
-            <a:spAutoFit/>
-          </a:bodyPr>
-          <a:lstStyle/>
-          <a:p>
-            <a:pPr algn="l"/>
-            <a:r>
-              <a:rPr sz="1400" b="1">
-                <a:solidFill>
-                  <a:srgbClr val="F59E0B"/>
-                </a:solidFill>
-                <a:latin typeface="Arial"/>
-              </a:rPr>
-              <a:t>Verify</a:t>
-            </a:r>
-          </a:p>
-        </p:txBody>
-      </p:sp>
-      <p:sp>
-        <p:nvSpPr>
-          <p:cNvPr id="31" name="TextBox 30"/>
-          <p:cNvSpPr txBox="1"/>
-          <p:nvPr/>
-        </p:nvSpPr>
-        <p:spPr>
-          <a:xfrm>
-            <a:off x="8085124" y="2487168"/>
-            <a:ext cx="1009497" cy="2852928"/>
-          </a:xfrm>
-          <a:prstGeom prst="rect">
-            <a:avLst/>
-          </a:prstGeom>
-          <a:noFill/>
-        </p:spPr>
-        <p:txBody>
-          <a:bodyPr wrap="square" anchor="t">
-            <a:spAutoFit/>
-          </a:bodyPr>
-          <a:lstStyle/>
-          <a:p>
-            <a:pPr algn="l"/>
-            <a:r>
-              <a:rPr sz="1150" b="0">
-                <a:solidFill>
-                  <a:srgbClr val="161B26"/>
-                </a:solidFill>
-                <a:latin typeface="Arial"/>
-              </a:rPr>
-              <a:t>Reproduce critical calculations and trace every claim to a source.</a:t>
-            </a:r>
-          </a:p>
-        </p:txBody>
-      </p:sp>
-      <p:sp>
-        <p:nvSpPr>
-          <p:cNvPr id="32" name="Rounded Rectangle 31"/>
-          <p:cNvSpPr/>
-          <p:nvPr/>
-        </p:nvSpPr>
-        <p:spPr>
-          <a:xfrm>
-            <a:off x="9478670" y="1920240"/>
-            <a:ext cx="1997049" cy="3566160"/>
-          </a:xfrm>
-          <a:prstGeom prst="roundRect">
-            <a:avLst/>
-          </a:prstGeom>
-          <a:solidFill>
-            <a:srgbClr val="F5F8FC"/>
-          </a:solidFill>
-          <a:ln>
-            <a:solidFill>
-              <a:srgbClr val="E2E8F0"/>
-            </a:solidFill>
-          </a:ln>
-        </p:spPr>
-        <p:style>
-          <a:lnRef idx="1">
-            <a:schemeClr val="accent1"/>
-          </a:lnRef>
-          <a:fillRef idx="3">
-            <a:schemeClr val="accent1"/>
-          </a:fillRef>
-          <a:effectRef idx="2">
-            <a:schemeClr val="accent1"/>
-          </a:effectRef>
-          <a:fontRef idx="minor">
-            <a:schemeClr val="lt1"/>
-          </a:fontRef>
-        </p:style>
-        <p:txBody>
-          <a:bodyPr rtlCol="0" anchor="ctr"/>
-          <a:lstStyle/>
-          <a:p>
-            <a:pPr algn="ctr"/>
-          </a:p>
-        </p:txBody>
-      </p:sp>
-      <p:sp>
-        <p:nvSpPr>
-          <p:cNvPr id="33" name="Rectangle 32"/>
-          <p:cNvSpPr/>
-          <p:nvPr/>
-        </p:nvSpPr>
-        <p:spPr>
-          <a:xfrm>
-            <a:off x="9478670" y="1920240"/>
-            <a:ext cx="73152" cy="3566160"/>
-          </a:xfrm>
-          <a:prstGeom prst="rect">
-            <a:avLst/>
-          </a:prstGeom>
-          <a:solidFill>
-            <a:srgbClr val="1F6FEB"/>
-          </a:solidFill>
-          <a:ln>
-            <a:solidFill>
-              <a:srgbClr val="1F6FEB"/>
-            </a:solidFill>
-          </a:ln>
-        </p:spPr>
-        <p:style>
-          <a:lnRef idx="1">
-            <a:schemeClr val="accent1"/>
-          </a:lnRef>
-          <a:fillRef idx="3">
-            <a:schemeClr val="accent1"/>
-          </a:fillRef>
-          <a:effectRef idx="2">
-            <a:schemeClr val="accent1"/>
-          </a:effectRef>
-          <a:fontRef idx="minor">
-            <a:schemeClr val="lt1"/>
-          </a:fontRef>
-        </p:style>
-        <p:txBody>
-          <a:bodyPr rtlCol="0" anchor="ctr"/>
-          <a:lstStyle/>
-          <a:p>
-            <a:pPr algn="ctr"/>
-          </a:p>
-        </p:txBody>
-      </p:sp>
-      <p:sp>
-        <p:nvSpPr>
-          <p:cNvPr id="34" name="Rounded Rectangle 33"/>
-          <p:cNvSpPr/>
-          <p:nvPr/>
-        </p:nvSpPr>
-        <p:spPr>
-          <a:xfrm>
-            <a:off x="9679838" y="2139696"/>
-            <a:ext cx="438912" cy="438912"/>
-          </a:xfrm>
-          <a:prstGeom prst="roundRect">
-            <a:avLst/>
-          </a:prstGeom>
-          <a:solidFill>
-            <a:srgbClr val="1F6FEB"/>
-          </a:solidFill>
-          <a:ln>
-            <a:solidFill>
-              <a:srgbClr val="1F6FEB"/>
-            </a:solidFill>
-          </a:ln>
-        </p:spPr>
-        <p:style>
-          <a:lnRef idx="1">
-            <a:schemeClr val="accent1"/>
-          </a:lnRef>
-          <a:fillRef idx="3">
-            <a:schemeClr val="accent1"/>
-          </a:fillRef>
-          <a:effectRef idx="2">
-            <a:schemeClr val="accent1"/>
-          </a:effectRef>
-          <a:fontRef idx="minor">
-            <a:schemeClr val="lt1"/>
-          </a:fontRef>
-        </p:style>
-        <p:txBody>
-          <a:bodyPr rtlCol="0" anchor="ctr"/>
-          <a:lstStyle/>
-          <a:p>
-            <a:pPr algn="ctr"/>
-          </a:p>
-        </p:txBody>
-      </p:sp>
-      <p:sp>
-        <p:nvSpPr>
-          <p:cNvPr id="35" name="TextBox 34"/>
-          <p:cNvSpPr txBox="1"/>
-          <p:nvPr/>
-        </p:nvSpPr>
-        <p:spPr>
-          <a:xfrm>
-            <a:off x="9679838" y="2148840"/>
-            <a:ext cx="438912" cy="420624"/>
-          </a:xfrm>
-          <a:prstGeom prst="rect">
-            <a:avLst/>
-          </a:prstGeom>
-          <a:noFill/>
-        </p:spPr>
-        <p:txBody>
-          <a:bodyPr wrap="square" anchor="ctr">
-            <a:spAutoFit/>
-          </a:bodyPr>
-          <a:lstStyle/>
-          <a:p>
-            <a:pPr algn="ctr"/>
-            <a:r>
-              <a:rPr sz="1400" b="1">
-                <a:solidFill>
-                  <a:srgbClr val="FFFFFF"/>
-                </a:solidFill>
-                <a:latin typeface="Arial"/>
-              </a:rPr>
-              <a:t>5</a:t>
-            </a:r>
-          </a:p>
-        </p:txBody>
-      </p:sp>
-      <p:sp>
-        <p:nvSpPr>
-          <p:cNvPr id="36" name="TextBox 35"/>
-          <p:cNvSpPr txBox="1"/>
-          <p:nvPr/>
-        </p:nvSpPr>
-        <p:spPr>
-          <a:xfrm>
-            <a:off x="10283342" y="2103120"/>
-            <a:ext cx="1009497" cy="329184"/>
-          </a:xfrm>
-          <a:prstGeom prst="rect">
-            <a:avLst/>
-          </a:prstGeom>
-          <a:noFill/>
-        </p:spPr>
-        <p:txBody>
-          <a:bodyPr wrap="square" anchor="t">
-            <a:spAutoFit/>
-          </a:bodyPr>
-          <a:lstStyle/>
-          <a:p>
-            <a:pPr algn="l"/>
-            <a:r>
-              <a:rPr sz="1400" b="1">
-                <a:solidFill>
-                  <a:srgbClr val="1F6FEB"/>
-                </a:solidFill>
-                <a:latin typeface="Arial"/>
-              </a:rPr>
-              <a:t>Extract</a:t>
-            </a:r>
-          </a:p>
-        </p:txBody>
-      </p:sp>
-      <p:sp>
-        <p:nvSpPr>
-          <p:cNvPr id="37" name="TextBox 36"/>
-          <p:cNvSpPr txBox="1"/>
-          <p:nvPr/>
-        </p:nvSpPr>
-        <p:spPr>
-          <a:xfrm>
-            <a:off x="10283342" y="2487168"/>
-            <a:ext cx="1009497" cy="2852928"/>
-          </a:xfrm>
-          <a:prstGeom prst="rect">
-            <a:avLst/>
-          </a:prstGeom>
-          <a:noFill/>
-        </p:spPr>
-        <p:txBody>
-          <a:bodyPr wrap="square" anchor="t">
-            <a:spAutoFit/>
-          </a:bodyPr>
-          <a:lstStyle/>
-          <a:p>
-            <a:pPr algn="l"/>
-            <a:r>
-              <a:rPr sz="1150" b="0">
-                <a:solidFill>
-                  <a:srgbClr val="161B26"/>
-                </a:solidFill>
-                <a:latin typeface="Arial"/>
-              </a:rPr>
-              <a:t>Write show–mean–matter–act insights with caveats.</a:t>
+              <a:t>Use Microsoft 365 Copilot with the supplied approved data summary to propose candidate insights. Verify every number in Excel before recommending one next step.</a:t>
             </a:r>
           </a:p>
         </p:txBody>
@@ -6940,11 +6626,11 @@
             <a:avLst/>
           </a:prstGeom>
           <a:solidFill>
-            <a:srgbClr val="7C3AED"/>
+            <a:srgbClr val="10B981"/>
           </a:solidFill>
           <a:ln>
             <a:solidFill>
-              <a:srgbClr val="7C3AED"/>
+              <a:srgbClr val="10B981"/>
             </a:solidFill>
           </a:ln>
         </p:spPr>
@@ -6996,11 +6682,11 @@
             <a:r>
               <a:rPr sz="1100" b="1">
                 <a:solidFill>
-                  <a:srgbClr val="7C3AED"/>
+                  <a:srgbClr val="10B981"/>
                 </a:solidFill>
                 <a:latin typeface="Arial"/>
               </a:rPr>
-              <a:t>ACTIVITY 01 · EXAMPLE</a:t>
+              <a:t>ACTIVITY 01 · FRAMEWORK</a:t>
             </a:r>
           </a:p>
         </p:txBody>
@@ -7035,7 +6721,7 @@
                 </a:solidFill>
                 <a:latin typeface="Arial"/>
               </a:rPr>
-              <a:t>Worked Output</a:t>
+              <a:t>Collect, Clean, Analyse, Verify</a:t>
             </a:r>
           </a:p>
         </p:txBody>
@@ -7128,8 +6814,8 @@
         </p:nvSpPr>
         <p:spPr>
           <a:xfrm>
-            <a:off x="731520" y="1783080"/>
-            <a:ext cx="3401568" cy="1719072"/>
+            <a:off x="685800" y="1920240"/>
+            <a:ext cx="1997049" cy="3566160"/>
           </a:xfrm>
           <a:prstGeom prst="roundRect">
             <a:avLst/>
@@ -7173,8 +6859,8 @@
         </p:nvSpPr>
         <p:spPr>
           <a:xfrm>
-            <a:off x="731520" y="1783080"/>
-            <a:ext cx="73152" cy="1719072"/>
+            <a:off x="685800" y="1920240"/>
+            <a:ext cx="73152" cy="3566160"/>
           </a:xfrm>
           <a:prstGeom prst="rect">
             <a:avLst/>
@@ -7218,7 +6904,7 @@
         </p:nvSpPr>
         <p:spPr>
           <a:xfrm>
-            <a:off x="932688" y="2002536"/>
+            <a:off x="886968" y="2139696"/>
             <a:ext cx="438912" cy="438912"/>
           </a:xfrm>
           <a:prstGeom prst="roundRect">
@@ -7263,7 +6949,7 @@
         </p:nvSpPr>
         <p:spPr>
           <a:xfrm>
-            <a:off x="932688" y="2011680"/>
+            <a:off x="886968" y="2148840"/>
             <a:ext cx="438912" cy="420624"/>
           </a:xfrm>
           <a:prstGeom prst="rect">
@@ -7298,8 +6984,8 @@
         </p:nvSpPr>
         <p:spPr>
           <a:xfrm>
-            <a:off x="1536192" y="1965960"/>
-            <a:ext cx="2414016" cy="329184"/>
+            <a:off x="1490472" y="2103120"/>
+            <a:ext cx="1009497" cy="329184"/>
           </a:xfrm>
           <a:prstGeom prst="rect">
             <a:avLst/>
@@ -7320,7 +7006,7 @@
                 </a:solidFill>
                 <a:latin typeface="Arial"/>
               </a:rPr>
-              <a:t>78%</a:t>
+              <a:t>Collect</a:t>
             </a:r>
           </a:p>
         </p:txBody>
@@ -7333,8 +7019,8 @@
         </p:nvSpPr>
         <p:spPr>
           <a:xfrm>
-            <a:off x="1536192" y="2350008"/>
-            <a:ext cx="2414016" cy="1005839"/>
+            <a:off x="1490472" y="2487168"/>
+            <a:ext cx="1009497" cy="2852928"/>
           </a:xfrm>
           <a:prstGeom prst="rect">
             <a:avLst/>
@@ -7355,7 +7041,7 @@
                 </a:solidFill>
                 <a:latin typeface="Arial"/>
               </a:rPr>
-              <a:t>Overall satisfaction</a:t>
+              <a:t>Register the approved CSV, workbook and research notes.</a:t>
             </a:r>
           </a:p>
         </p:txBody>
@@ -7368,8 +7054,8 @@
         </p:nvSpPr>
         <p:spPr>
           <a:xfrm>
-            <a:off x="4315968" y="1783080"/>
-            <a:ext cx="3401568" cy="1719072"/>
+            <a:off x="2884017" y="1920240"/>
+            <a:ext cx="1997049" cy="3566160"/>
           </a:xfrm>
           <a:prstGeom prst="roundRect">
             <a:avLst/>
@@ -7413,8 +7099,8 @@
         </p:nvSpPr>
         <p:spPr>
           <a:xfrm>
-            <a:off x="4315968" y="1783080"/>
-            <a:ext cx="73152" cy="1719072"/>
+            <a:off x="2884017" y="1920240"/>
+            <a:ext cx="73152" cy="3566160"/>
           </a:xfrm>
           <a:prstGeom prst="rect">
             <a:avLst/>
@@ -7458,7 +7144,7 @@
         </p:nvSpPr>
         <p:spPr>
           <a:xfrm>
-            <a:off x="4517136" y="2002536"/>
+            <a:off x="3085185" y="2139696"/>
             <a:ext cx="438912" cy="438912"/>
           </a:xfrm>
           <a:prstGeom prst="roundRect">
@@ -7503,7 +7189,7 @@
         </p:nvSpPr>
         <p:spPr>
           <a:xfrm>
-            <a:off x="4517136" y="2011680"/>
+            <a:off x="3085185" y="2148840"/>
             <a:ext cx="438912" cy="420624"/>
           </a:xfrm>
           <a:prstGeom prst="rect">
@@ -7538,8 +7224,8 @@
         </p:nvSpPr>
         <p:spPr>
           <a:xfrm>
-            <a:off x="5120640" y="1965960"/>
-            <a:ext cx="2414016" cy="329184"/>
+            <a:off x="3688689" y="2103120"/>
+            <a:ext cx="1009497" cy="329184"/>
           </a:xfrm>
           <a:prstGeom prst="rect">
             <a:avLst/>
@@ -7560,7 +7246,7 @@
                 </a:solidFill>
                 <a:latin typeface="Arial"/>
               </a:rPr>
-              <a:t>86%</a:t>
+              <a:t>Clean</a:t>
             </a:r>
           </a:p>
         </p:txBody>
@@ -7573,8 +7259,8 @@
         </p:nvSpPr>
         <p:spPr>
           <a:xfrm>
-            <a:off x="5120640" y="2350008"/>
-            <a:ext cx="2414016" cy="1005839"/>
+            <a:off x="3688689" y="2487168"/>
+            <a:ext cx="1009497" cy="2852928"/>
           </a:xfrm>
           <a:prstGeom prst="rect">
             <a:avLst/>
@@ -7595,7 +7281,7 @@
                 </a:solidFill>
                 <a:latin typeface="Arial"/>
               </a:rPr>
-              <a:t>Repeat-customer satisfaction</a:t>
+              <a:t>Standardise labels, units and missing-value handling without changing raw evidence.</a:t>
             </a:r>
           </a:p>
         </p:txBody>
@@ -7608,8 +7294,8 @@
         </p:nvSpPr>
         <p:spPr>
           <a:xfrm>
-            <a:off x="7900416" y="1783080"/>
-            <a:ext cx="3401568" cy="1719072"/>
+            <a:off x="5082235" y="1920240"/>
+            <a:ext cx="1997049" cy="3566160"/>
           </a:xfrm>
           <a:prstGeom prst="roundRect">
             <a:avLst/>
@@ -7653,8 +7339,8 @@
         </p:nvSpPr>
         <p:spPr>
           <a:xfrm>
-            <a:off x="7900416" y="1783080"/>
-            <a:ext cx="73152" cy="1719072"/>
+            <a:off x="5082235" y="1920240"/>
+            <a:ext cx="73152" cy="3566160"/>
           </a:xfrm>
           <a:prstGeom prst="rect">
             <a:avLst/>
@@ -7698,7 +7384,7 @@
         </p:nvSpPr>
         <p:spPr>
           <a:xfrm>
-            <a:off x="8101584" y="2002536"/>
+            <a:off x="5283403" y="2139696"/>
             <a:ext cx="438912" cy="438912"/>
           </a:xfrm>
           <a:prstGeom prst="roundRect">
@@ -7743,7 +7429,7 @@
         </p:nvSpPr>
         <p:spPr>
           <a:xfrm>
-            <a:off x="8101584" y="2011680"/>
+            <a:off x="5283403" y="2148840"/>
             <a:ext cx="438912" cy="420624"/>
           </a:xfrm>
           <a:prstGeom prst="rect">
@@ -7778,8 +7464,8 @@
         </p:nvSpPr>
         <p:spPr>
           <a:xfrm>
-            <a:off x="8705088" y="1965960"/>
-            <a:ext cx="2414016" cy="329184"/>
+            <a:off x="5886907" y="2103120"/>
+            <a:ext cx="1009497" cy="329184"/>
           </a:xfrm>
           <a:prstGeom prst="rect">
             <a:avLst/>
@@ -7800,7 +7486,7 @@
                 </a:solidFill>
                 <a:latin typeface="Arial"/>
               </a:rPr>
-              <a:t>69%</a:t>
+              <a:t>Analyse</a:t>
             </a:r>
           </a:p>
         </p:txBody>
@@ -7813,8 +7499,8 @@
         </p:nvSpPr>
         <p:spPr>
           <a:xfrm>
-            <a:off x="8705088" y="2350008"/>
-            <a:ext cx="2414016" cy="1005839"/>
+            <a:off x="5886907" y="2487168"/>
+            <a:ext cx="1009497" cy="2852928"/>
           </a:xfrm>
           <a:prstGeom prst="rect">
             <a:avLst/>
@@ -7835,7 +7521,7 @@
                 </a:solidFill>
                 <a:latin typeface="Arial"/>
               </a:rPr>
-              <a:t>First-time-customer satisfaction</a:t>
+              <a:t>Prompt AI for patterns, exceptions and competing explanations.</a:t>
             </a:r>
           </a:p>
         </p:txBody>
@@ -7848,8 +7534,8 @@
         </p:nvSpPr>
         <p:spPr>
           <a:xfrm>
-            <a:off x="731520" y="3776472"/>
-            <a:ext cx="3401568" cy="1719072"/>
+            <a:off x="7280452" y="1920240"/>
+            <a:ext cx="1997049" cy="3566160"/>
           </a:xfrm>
           <a:prstGeom prst="roundRect">
             <a:avLst/>
@@ -7893,8 +7579,8 @@
         </p:nvSpPr>
         <p:spPr>
           <a:xfrm>
-            <a:off x="731520" y="3776472"/>
-            <a:ext cx="73152" cy="1719072"/>
+            <a:off x="7280452" y="1920240"/>
+            <a:ext cx="73152" cy="3566160"/>
           </a:xfrm>
           <a:prstGeom prst="rect">
             <a:avLst/>
@@ -7938,7 +7624,7 @@
         </p:nvSpPr>
         <p:spPr>
           <a:xfrm>
-            <a:off x="932688" y="3995928"/>
+            <a:off x="7481620" y="2139696"/>
             <a:ext cx="438912" cy="438912"/>
           </a:xfrm>
           <a:prstGeom prst="roundRect">
@@ -7983,7 +7669,7 @@
         </p:nvSpPr>
         <p:spPr>
           <a:xfrm>
-            <a:off x="932688" y="4005072"/>
+            <a:off x="7481620" y="2148840"/>
             <a:ext cx="438912" cy="420624"/>
           </a:xfrm>
           <a:prstGeom prst="rect">
@@ -8018,8 +7704,8 @@
         </p:nvSpPr>
         <p:spPr>
           <a:xfrm>
-            <a:off x="1536192" y="3959352"/>
-            <a:ext cx="2414016" cy="329184"/>
+            <a:off x="8085124" y="2103120"/>
+            <a:ext cx="1009497" cy="329184"/>
           </a:xfrm>
           <a:prstGeom prst="rect">
             <a:avLst/>
@@ -8040,7 +7726,7 @@
                 </a:solidFill>
                 <a:latin typeface="Arial"/>
               </a:rPr>
-              <a:t>+11 pts</a:t>
+              <a:t>Verify</a:t>
             </a:r>
           </a:p>
         </p:txBody>
@@ -8053,8 +7739,8 @@
         </p:nvSpPr>
         <p:spPr>
           <a:xfrm>
-            <a:off x="1536192" y="4343400"/>
-            <a:ext cx="2414016" cy="1005839"/>
+            <a:off x="8085124" y="2487168"/>
+            <a:ext cx="1009497" cy="2852928"/>
           </a:xfrm>
           <a:prstGeom prst="rect">
             <a:avLst/>
@@ -8075,7 +7761,7 @@
                 </a:solidFill>
                 <a:latin typeface="Arial"/>
               </a:rPr>
-              <a:t>Mobile-app users vs non-users</a:t>
+              <a:t>Reproduce critical calculations and trace every claim to a source.</a:t>
             </a:r>
           </a:p>
         </p:txBody>
@@ -8088,8 +7774,8 @@
         </p:nvSpPr>
         <p:spPr>
           <a:xfrm>
-            <a:off x="4315968" y="3776472"/>
-            <a:ext cx="3401568" cy="1719072"/>
+            <a:off x="9478670" y="1920240"/>
+            <a:ext cx="1997049" cy="3566160"/>
           </a:xfrm>
           <a:prstGeom prst="roundRect">
             <a:avLst/>
@@ -8133,8 +7819,8 @@
         </p:nvSpPr>
         <p:spPr>
           <a:xfrm>
-            <a:off x="4315968" y="3776472"/>
-            <a:ext cx="73152" cy="1719072"/>
+            <a:off x="9478670" y="1920240"/>
+            <a:ext cx="73152" cy="3566160"/>
           </a:xfrm>
           <a:prstGeom prst="rect">
             <a:avLst/>
@@ -8178,7 +7864,7 @@
         </p:nvSpPr>
         <p:spPr>
           <a:xfrm>
-            <a:off x="4517136" y="3995928"/>
+            <a:off x="9679838" y="2139696"/>
             <a:ext cx="438912" cy="438912"/>
           </a:xfrm>
           <a:prstGeom prst="roundRect">
@@ -8223,7 +7909,7 @@
         </p:nvSpPr>
         <p:spPr>
           <a:xfrm>
-            <a:off x="4517136" y="4005072"/>
+            <a:off x="9679838" y="2148840"/>
             <a:ext cx="438912" cy="420624"/>
           </a:xfrm>
           <a:prstGeom prst="rect">
@@ -8258,8 +7944,8 @@
         </p:nvSpPr>
         <p:spPr>
           <a:xfrm>
-            <a:off x="5120640" y="3959352"/>
-            <a:ext cx="2414016" cy="329184"/>
+            <a:off x="10283342" y="2103120"/>
+            <a:ext cx="1009497" cy="329184"/>
           </a:xfrm>
           <a:prstGeom prst="rect">
             <a:avLst/>
@@ -8280,7 +7966,7 @@
                 </a:solidFill>
                 <a:latin typeface="Arial"/>
               </a:rPr>
-              <a:t>420</a:t>
+              <a:t>Extract</a:t>
             </a:r>
           </a:p>
         </p:txBody>
@@ -8293,8 +7979,8 @@
         </p:nvSpPr>
         <p:spPr>
           <a:xfrm>
-            <a:off x="5120640" y="4343400"/>
-            <a:ext cx="2414016" cy="1005839"/>
+            <a:off x="10283342" y="2487168"/>
+            <a:ext cx="1009497" cy="2852928"/>
           </a:xfrm>
           <a:prstGeom prst="rect">
             <a:avLst/>
@@ -8315,247 +8001,7 @@
                 </a:solidFill>
                 <a:latin typeface="Arial"/>
               </a:rPr>
-              <a:t>Survey responses</a:t>
-            </a:r>
-          </a:p>
-        </p:txBody>
-      </p:sp>
-      <p:sp>
-        <p:nvSpPr>
-          <p:cNvPr id="38" name="Rounded Rectangle 37"/>
-          <p:cNvSpPr/>
-          <p:nvPr/>
-        </p:nvSpPr>
-        <p:spPr>
-          <a:xfrm>
-            <a:off x="7900416" y="3776472"/>
-            <a:ext cx="3401568" cy="1719072"/>
-          </a:xfrm>
-          <a:prstGeom prst="roundRect">
-            <a:avLst/>
-          </a:prstGeom>
-          <a:solidFill>
-            <a:srgbClr val="F5F8FC"/>
-          </a:solidFill>
-          <a:ln>
-            <a:solidFill>
-              <a:srgbClr val="E2E8F0"/>
-            </a:solidFill>
-          </a:ln>
-        </p:spPr>
-        <p:style>
-          <a:lnRef idx="1">
-            <a:schemeClr val="accent1"/>
-          </a:lnRef>
-          <a:fillRef idx="3">
-            <a:schemeClr val="accent1"/>
-          </a:fillRef>
-          <a:effectRef idx="2">
-            <a:schemeClr val="accent1"/>
-          </a:effectRef>
-          <a:fontRef idx="minor">
-            <a:schemeClr val="lt1"/>
-          </a:fontRef>
-        </p:style>
-        <p:txBody>
-          <a:bodyPr rtlCol="0" anchor="ctr"/>
-          <a:lstStyle/>
-          <a:p>
-            <a:pPr algn="ctr"/>
-          </a:p>
-        </p:txBody>
-      </p:sp>
-      <p:sp>
-        <p:nvSpPr>
-          <p:cNvPr id="39" name="Rectangle 38"/>
-          <p:cNvSpPr/>
-          <p:nvPr/>
-        </p:nvSpPr>
-        <p:spPr>
-          <a:xfrm>
-            <a:off x="7900416" y="3776472"/>
-            <a:ext cx="73152" cy="1719072"/>
-          </a:xfrm>
-          <a:prstGeom prst="rect">
-            <a:avLst/>
-          </a:prstGeom>
-          <a:solidFill>
-            <a:srgbClr val="10B981"/>
-          </a:solidFill>
-          <a:ln>
-            <a:solidFill>
-              <a:srgbClr val="10B981"/>
-            </a:solidFill>
-          </a:ln>
-        </p:spPr>
-        <p:style>
-          <a:lnRef idx="1">
-            <a:schemeClr val="accent1"/>
-          </a:lnRef>
-          <a:fillRef idx="3">
-            <a:schemeClr val="accent1"/>
-          </a:fillRef>
-          <a:effectRef idx="2">
-            <a:schemeClr val="accent1"/>
-          </a:effectRef>
-          <a:fontRef idx="minor">
-            <a:schemeClr val="lt1"/>
-          </a:fontRef>
-        </p:style>
-        <p:txBody>
-          <a:bodyPr rtlCol="0" anchor="ctr"/>
-          <a:lstStyle/>
-          <a:p>
-            <a:pPr algn="ctr"/>
-          </a:p>
-        </p:txBody>
-      </p:sp>
-      <p:sp>
-        <p:nvSpPr>
-          <p:cNvPr id="40" name="Rounded Rectangle 39"/>
-          <p:cNvSpPr/>
-          <p:nvPr/>
-        </p:nvSpPr>
-        <p:spPr>
-          <a:xfrm>
-            <a:off x="8101584" y="3995928"/>
-            <a:ext cx="438912" cy="438912"/>
-          </a:xfrm>
-          <a:prstGeom prst="roundRect">
-            <a:avLst/>
-          </a:prstGeom>
-          <a:solidFill>
-            <a:srgbClr val="10B981"/>
-          </a:solidFill>
-          <a:ln>
-            <a:solidFill>
-              <a:srgbClr val="10B981"/>
-            </a:solidFill>
-          </a:ln>
-        </p:spPr>
-        <p:style>
-          <a:lnRef idx="1">
-            <a:schemeClr val="accent1"/>
-          </a:lnRef>
-          <a:fillRef idx="3">
-            <a:schemeClr val="accent1"/>
-          </a:fillRef>
-          <a:effectRef idx="2">
-            <a:schemeClr val="accent1"/>
-          </a:effectRef>
-          <a:fontRef idx="minor">
-            <a:schemeClr val="lt1"/>
-          </a:fontRef>
-        </p:style>
-        <p:txBody>
-          <a:bodyPr rtlCol="0" anchor="ctr"/>
-          <a:lstStyle/>
-          <a:p>
-            <a:pPr algn="ctr"/>
-          </a:p>
-        </p:txBody>
-      </p:sp>
-      <p:sp>
-        <p:nvSpPr>
-          <p:cNvPr id="41" name="TextBox 40"/>
-          <p:cNvSpPr txBox="1"/>
-          <p:nvPr/>
-        </p:nvSpPr>
-        <p:spPr>
-          <a:xfrm>
-            <a:off x="8101584" y="4005072"/>
-            <a:ext cx="438912" cy="420624"/>
-          </a:xfrm>
-          <a:prstGeom prst="rect">
-            <a:avLst/>
-          </a:prstGeom>
-          <a:noFill/>
-        </p:spPr>
-        <p:txBody>
-          <a:bodyPr wrap="square" anchor="ctr">
-            <a:spAutoFit/>
-          </a:bodyPr>
-          <a:lstStyle/>
-          <a:p>
-            <a:pPr algn="ctr"/>
-            <a:r>
-              <a:rPr sz="1400" b="1">
-                <a:solidFill>
-                  <a:srgbClr val="FFFFFF"/>
-                </a:solidFill>
-                <a:latin typeface="Arial"/>
-              </a:rPr>
-              <a:t>6</a:t>
-            </a:r>
-          </a:p>
-        </p:txBody>
-      </p:sp>
-      <p:sp>
-        <p:nvSpPr>
-          <p:cNvPr id="42" name="TextBox 41"/>
-          <p:cNvSpPr txBox="1"/>
-          <p:nvPr/>
-        </p:nvSpPr>
-        <p:spPr>
-          <a:xfrm>
-            <a:off x="8705088" y="3959352"/>
-            <a:ext cx="2414016" cy="329184"/>
-          </a:xfrm>
-          <a:prstGeom prst="rect">
-            <a:avLst/>
-          </a:prstGeom>
-          <a:noFill/>
-        </p:spPr>
-        <p:txBody>
-          <a:bodyPr wrap="square" anchor="t">
-            <a:spAutoFit/>
-          </a:bodyPr>
-          <a:lstStyle/>
-          <a:p>
-            <a:pPr algn="l"/>
-            <a:r>
-              <a:rPr sz="1400" b="1">
-                <a:solidFill>
-                  <a:srgbClr val="10B981"/>
-                </a:solidFill>
-                <a:latin typeface="Arial"/>
-              </a:rPr>
-              <a:t>Q2 2026</a:t>
-            </a:r>
-          </a:p>
-        </p:txBody>
-      </p:sp>
-      <p:sp>
-        <p:nvSpPr>
-          <p:cNvPr id="43" name="TextBox 42"/>
-          <p:cNvSpPr txBox="1"/>
-          <p:nvPr/>
-        </p:nvSpPr>
-        <p:spPr>
-          <a:xfrm>
-            <a:off x="8705088" y="4343400"/>
-            <a:ext cx="2414016" cy="1005839"/>
-          </a:xfrm>
-          <a:prstGeom prst="rect">
-            <a:avLst/>
-          </a:prstGeom>
-          <a:noFill/>
-        </p:spPr>
-        <p:txBody>
-          <a:bodyPr wrap="square" anchor="t">
-            <a:spAutoFit/>
-          </a:bodyPr>
-          <a:lstStyle/>
-          <a:p>
-            <a:pPr algn="l"/>
-            <a:r>
-              <a:rPr sz="1150" b="0">
-                <a:solidFill>
-                  <a:srgbClr val="161B26"/>
-                </a:solidFill>
-                <a:latin typeface="Arial"/>
-              </a:rPr>
-              <a:t>Synthetic reporting period</a:t>
+              <a:t>Write show–mean–matter–act insights with caveats.</a:t>
             </a:r>
           </a:p>
         </p:txBody>
@@ -8638,11 +8084,11 @@
             <a:avLst/>
           </a:prstGeom>
           <a:solidFill>
-            <a:srgbClr val="1F6FEB"/>
+            <a:srgbClr val="7C3AED"/>
           </a:solidFill>
           <a:ln>
             <a:solidFill>
-              <a:srgbClr val="1F6FEB"/>
+              <a:srgbClr val="7C3AED"/>
             </a:solidFill>
           </a:ln>
         </p:spPr>
@@ -8694,11 +8140,11 @@
             <a:r>
               <a:rPr sz="1100" b="1">
                 <a:solidFill>
-                  <a:srgbClr val="1F6FEB"/>
+                  <a:srgbClr val="7C3AED"/>
                 </a:solidFill>
                 <a:latin typeface="Arial"/>
               </a:rPr>
-              <a:t>ACTIVITY 01 · ACCEPTANCE</a:t>
+              <a:t>ACTIVITY 01 · EXAMPLE</a:t>
             </a:r>
           </a:p>
         </p:txBody>
@@ -8733,7 +8179,7 @@
                 </a:solidFill>
                 <a:latin typeface="Arial"/>
               </a:rPr>
-              <a:t>What Good Looks Like</a:t>
+              <a:t>Worked Output</a:t>
             </a:r>
           </a:p>
         </p:txBody>
@@ -8826,10 +8272,55 @@
         </p:nvSpPr>
         <p:spPr>
           <a:xfrm>
-            <a:off x="749808" y="1810512"/>
-            <a:ext cx="10652760" cy="1005840"/>
+            <a:off x="731520" y="1783080"/>
+            <a:ext cx="3401568" cy="1719072"/>
           </a:xfrm>
           <a:prstGeom prst="roundRect">
+            <a:avLst/>
+          </a:prstGeom>
+          <a:solidFill>
+            <a:srgbClr val="F5F8FC"/>
+          </a:solidFill>
+          <a:ln>
+            <a:solidFill>
+              <a:srgbClr val="E2E8F0"/>
+            </a:solidFill>
+          </a:ln>
+        </p:spPr>
+        <p:style>
+          <a:lnRef idx="1">
+            <a:schemeClr val="accent1"/>
+          </a:lnRef>
+          <a:fillRef idx="3">
+            <a:schemeClr val="accent1"/>
+          </a:fillRef>
+          <a:effectRef idx="2">
+            <a:schemeClr val="accent1"/>
+          </a:effectRef>
+          <a:fontRef idx="minor">
+            <a:schemeClr val="lt1"/>
+          </a:fontRef>
+        </p:style>
+        <p:txBody>
+          <a:bodyPr rtlCol="0" anchor="ctr"/>
+          <a:lstStyle/>
+          <a:p>
+            <a:pPr algn="ctr"/>
+          </a:p>
+        </p:txBody>
+      </p:sp>
+      <p:sp>
+        <p:nvSpPr>
+          <p:cNvPr id="9" name="Rectangle 8"/>
+          <p:cNvSpPr/>
+          <p:nvPr/>
+        </p:nvSpPr>
+        <p:spPr>
+          <a:xfrm>
+            <a:off x="731520" y="1783080"/>
+            <a:ext cx="73152" cy="1719072"/>
+          </a:xfrm>
+          <a:prstGeom prst="rect">
             <a:avLst/>
           </a:prstGeom>
           <a:solidFill>
@@ -8865,14 +8356,59 @@
       </p:sp>
       <p:sp>
         <p:nvSpPr>
-          <p:cNvPr id="9" name="TextBox 8"/>
+          <p:cNvPr id="10" name="Rounded Rectangle 9"/>
+          <p:cNvSpPr/>
+          <p:nvPr/>
+        </p:nvSpPr>
+        <p:spPr>
+          <a:xfrm>
+            <a:off x="932688" y="2002536"/>
+            <a:ext cx="438912" cy="438912"/>
+          </a:xfrm>
+          <a:prstGeom prst="roundRect">
+            <a:avLst/>
+          </a:prstGeom>
+          <a:solidFill>
+            <a:srgbClr val="1F6FEB"/>
+          </a:solidFill>
+          <a:ln>
+            <a:solidFill>
+              <a:srgbClr val="1F6FEB"/>
+            </a:solidFill>
+          </a:ln>
+        </p:spPr>
+        <p:style>
+          <a:lnRef idx="1">
+            <a:schemeClr val="accent1"/>
+          </a:lnRef>
+          <a:fillRef idx="3">
+            <a:schemeClr val="accent1"/>
+          </a:fillRef>
+          <a:effectRef idx="2">
+            <a:schemeClr val="accent1"/>
+          </a:effectRef>
+          <a:fontRef idx="minor">
+            <a:schemeClr val="lt1"/>
+          </a:fontRef>
+        </p:style>
+        <p:txBody>
+          <a:bodyPr rtlCol="0" anchor="ctr"/>
+          <a:lstStyle/>
+          <a:p>
+            <a:pPr algn="ctr"/>
+          </a:p>
+        </p:txBody>
+      </p:sp>
+      <p:sp>
+        <p:nvSpPr>
+          <p:cNvPr id="11" name="TextBox 10"/>
           <p:cNvSpPr txBox="1"/>
           <p:nvPr/>
         </p:nvSpPr>
         <p:spPr>
           <a:xfrm>
-            <a:off x="1051560" y="2011680"/>
-            <a:ext cx="10058400" cy="566928"/>
+            <a:off x="932688" y="2011680"/>
+            <a:ext cx="438912" cy="420624"/>
           </a:xfrm>
           <a:prstGeom prst="rect">
             <a:avLst/>
@@ -8887,13 +8423,1621 @@
           <a:p>
             <a:pPr algn="ctr"/>
             <a:r>
-              <a:rPr sz="1900" b="1">
+              <a:rPr sz="1400" b="1">
                 <a:solidFill>
                   <a:srgbClr val="FFFFFF"/>
                 </a:solidFill>
                 <a:latin typeface="Arial"/>
               </a:rPr>
-              <a:t>A cleaned analysis workbook, AI prompt/source log, annotated insight slide and one-sentence recommendation</a:t>
+              <a:t>1</a:t>
+            </a:r>
+          </a:p>
+        </p:txBody>
+      </p:sp>
+      <p:sp>
+        <p:nvSpPr>
+          <p:cNvPr id="12" name="TextBox 11"/>
+          <p:cNvSpPr txBox="1"/>
+          <p:nvPr/>
+        </p:nvSpPr>
+        <p:spPr>
+          <a:xfrm>
+            <a:off x="1536192" y="1965960"/>
+            <a:ext cx="2414016" cy="329184"/>
+          </a:xfrm>
+          <a:prstGeom prst="rect">
+            <a:avLst/>
+          </a:prstGeom>
+          <a:noFill/>
+        </p:spPr>
+        <p:txBody>
+          <a:bodyPr wrap="square" anchor="t">
+            <a:spAutoFit/>
+          </a:bodyPr>
+          <a:lstStyle/>
+          <a:p>
+            <a:pPr algn="l"/>
+            <a:r>
+              <a:rPr sz="1400" b="1">
+                <a:solidFill>
+                  <a:srgbClr val="1F6FEB"/>
+                </a:solidFill>
+                <a:latin typeface="Arial"/>
+              </a:rPr>
+              <a:t>78%</a:t>
+            </a:r>
+          </a:p>
+        </p:txBody>
+      </p:sp>
+      <p:sp>
+        <p:nvSpPr>
+          <p:cNvPr id="13" name="TextBox 12"/>
+          <p:cNvSpPr txBox="1"/>
+          <p:nvPr/>
+        </p:nvSpPr>
+        <p:spPr>
+          <a:xfrm>
+            <a:off x="1536192" y="2350008"/>
+            <a:ext cx="2414016" cy="1005839"/>
+          </a:xfrm>
+          <a:prstGeom prst="rect">
+            <a:avLst/>
+          </a:prstGeom>
+          <a:noFill/>
+        </p:spPr>
+        <p:txBody>
+          <a:bodyPr wrap="square" anchor="t">
+            <a:spAutoFit/>
+          </a:bodyPr>
+          <a:lstStyle/>
+          <a:p>
+            <a:pPr algn="l"/>
+            <a:r>
+              <a:rPr sz="1150" b="0">
+                <a:solidFill>
+                  <a:srgbClr val="161B26"/>
+                </a:solidFill>
+                <a:latin typeface="Arial"/>
+              </a:rPr>
+              <a:t>Overall satisfaction</a:t>
+            </a:r>
+          </a:p>
+        </p:txBody>
+      </p:sp>
+      <p:sp>
+        <p:nvSpPr>
+          <p:cNvPr id="14" name="Rounded Rectangle 13"/>
+          <p:cNvSpPr/>
+          <p:nvPr/>
+        </p:nvSpPr>
+        <p:spPr>
+          <a:xfrm>
+            <a:off x="4315968" y="1783080"/>
+            <a:ext cx="3401568" cy="1719072"/>
+          </a:xfrm>
+          <a:prstGeom prst="roundRect">
+            <a:avLst/>
+          </a:prstGeom>
+          <a:solidFill>
+            <a:srgbClr val="F5F8FC"/>
+          </a:solidFill>
+          <a:ln>
+            <a:solidFill>
+              <a:srgbClr val="E2E8F0"/>
+            </a:solidFill>
+          </a:ln>
+        </p:spPr>
+        <p:style>
+          <a:lnRef idx="1">
+            <a:schemeClr val="accent1"/>
+          </a:lnRef>
+          <a:fillRef idx="3">
+            <a:schemeClr val="accent1"/>
+          </a:fillRef>
+          <a:effectRef idx="2">
+            <a:schemeClr val="accent1"/>
+          </a:effectRef>
+          <a:fontRef idx="minor">
+            <a:schemeClr val="lt1"/>
+          </a:fontRef>
+        </p:style>
+        <p:txBody>
+          <a:bodyPr rtlCol="0" anchor="ctr"/>
+          <a:lstStyle/>
+          <a:p>
+            <a:pPr algn="ctr"/>
+          </a:p>
+        </p:txBody>
+      </p:sp>
+      <p:sp>
+        <p:nvSpPr>
+          <p:cNvPr id="15" name="Rectangle 14"/>
+          <p:cNvSpPr/>
+          <p:nvPr/>
+        </p:nvSpPr>
+        <p:spPr>
+          <a:xfrm>
+            <a:off x="4315968" y="1783080"/>
+            <a:ext cx="73152" cy="1719072"/>
+          </a:xfrm>
+          <a:prstGeom prst="rect">
+            <a:avLst/>
+          </a:prstGeom>
+          <a:solidFill>
+            <a:srgbClr val="10B981"/>
+          </a:solidFill>
+          <a:ln>
+            <a:solidFill>
+              <a:srgbClr val="10B981"/>
+            </a:solidFill>
+          </a:ln>
+        </p:spPr>
+        <p:style>
+          <a:lnRef idx="1">
+            <a:schemeClr val="accent1"/>
+          </a:lnRef>
+          <a:fillRef idx="3">
+            <a:schemeClr val="accent1"/>
+          </a:fillRef>
+          <a:effectRef idx="2">
+            <a:schemeClr val="accent1"/>
+          </a:effectRef>
+          <a:fontRef idx="minor">
+            <a:schemeClr val="lt1"/>
+          </a:fontRef>
+        </p:style>
+        <p:txBody>
+          <a:bodyPr rtlCol="0" anchor="ctr"/>
+          <a:lstStyle/>
+          <a:p>
+            <a:pPr algn="ctr"/>
+          </a:p>
+        </p:txBody>
+      </p:sp>
+      <p:sp>
+        <p:nvSpPr>
+          <p:cNvPr id="16" name="Rounded Rectangle 15"/>
+          <p:cNvSpPr/>
+          <p:nvPr/>
+        </p:nvSpPr>
+        <p:spPr>
+          <a:xfrm>
+            <a:off x="4517136" y="2002536"/>
+            <a:ext cx="438912" cy="438912"/>
+          </a:xfrm>
+          <a:prstGeom prst="roundRect">
+            <a:avLst/>
+          </a:prstGeom>
+          <a:solidFill>
+            <a:srgbClr val="10B981"/>
+          </a:solidFill>
+          <a:ln>
+            <a:solidFill>
+              <a:srgbClr val="10B981"/>
+            </a:solidFill>
+          </a:ln>
+        </p:spPr>
+        <p:style>
+          <a:lnRef idx="1">
+            <a:schemeClr val="accent1"/>
+          </a:lnRef>
+          <a:fillRef idx="3">
+            <a:schemeClr val="accent1"/>
+          </a:fillRef>
+          <a:effectRef idx="2">
+            <a:schemeClr val="accent1"/>
+          </a:effectRef>
+          <a:fontRef idx="minor">
+            <a:schemeClr val="lt1"/>
+          </a:fontRef>
+        </p:style>
+        <p:txBody>
+          <a:bodyPr rtlCol="0" anchor="ctr"/>
+          <a:lstStyle/>
+          <a:p>
+            <a:pPr algn="ctr"/>
+          </a:p>
+        </p:txBody>
+      </p:sp>
+      <p:sp>
+        <p:nvSpPr>
+          <p:cNvPr id="17" name="TextBox 16"/>
+          <p:cNvSpPr txBox="1"/>
+          <p:nvPr/>
+        </p:nvSpPr>
+        <p:spPr>
+          <a:xfrm>
+            <a:off x="4517136" y="2011680"/>
+            <a:ext cx="438912" cy="420624"/>
+          </a:xfrm>
+          <a:prstGeom prst="rect">
+            <a:avLst/>
+          </a:prstGeom>
+          <a:noFill/>
+        </p:spPr>
+        <p:txBody>
+          <a:bodyPr wrap="square" anchor="ctr">
+            <a:spAutoFit/>
+          </a:bodyPr>
+          <a:lstStyle/>
+          <a:p>
+            <a:pPr algn="ctr"/>
+            <a:r>
+              <a:rPr sz="1400" b="1">
+                <a:solidFill>
+                  <a:srgbClr val="FFFFFF"/>
+                </a:solidFill>
+                <a:latin typeface="Arial"/>
+              </a:rPr>
+              <a:t>2</a:t>
+            </a:r>
+          </a:p>
+        </p:txBody>
+      </p:sp>
+      <p:sp>
+        <p:nvSpPr>
+          <p:cNvPr id="18" name="TextBox 17"/>
+          <p:cNvSpPr txBox="1"/>
+          <p:nvPr/>
+        </p:nvSpPr>
+        <p:spPr>
+          <a:xfrm>
+            <a:off x="5120640" y="1965960"/>
+            <a:ext cx="2414016" cy="329184"/>
+          </a:xfrm>
+          <a:prstGeom prst="rect">
+            <a:avLst/>
+          </a:prstGeom>
+          <a:noFill/>
+        </p:spPr>
+        <p:txBody>
+          <a:bodyPr wrap="square" anchor="t">
+            <a:spAutoFit/>
+          </a:bodyPr>
+          <a:lstStyle/>
+          <a:p>
+            <a:pPr algn="l"/>
+            <a:r>
+              <a:rPr sz="1400" b="1">
+                <a:solidFill>
+                  <a:srgbClr val="10B981"/>
+                </a:solidFill>
+                <a:latin typeface="Arial"/>
+              </a:rPr>
+              <a:t>86%</a:t>
+            </a:r>
+          </a:p>
+        </p:txBody>
+      </p:sp>
+      <p:sp>
+        <p:nvSpPr>
+          <p:cNvPr id="19" name="TextBox 18"/>
+          <p:cNvSpPr txBox="1"/>
+          <p:nvPr/>
+        </p:nvSpPr>
+        <p:spPr>
+          <a:xfrm>
+            <a:off x="5120640" y="2350008"/>
+            <a:ext cx="2414016" cy="1005839"/>
+          </a:xfrm>
+          <a:prstGeom prst="rect">
+            <a:avLst/>
+          </a:prstGeom>
+          <a:noFill/>
+        </p:spPr>
+        <p:txBody>
+          <a:bodyPr wrap="square" anchor="t">
+            <a:spAutoFit/>
+          </a:bodyPr>
+          <a:lstStyle/>
+          <a:p>
+            <a:pPr algn="l"/>
+            <a:r>
+              <a:rPr sz="1150" b="0">
+                <a:solidFill>
+                  <a:srgbClr val="161B26"/>
+                </a:solidFill>
+                <a:latin typeface="Arial"/>
+              </a:rPr>
+              <a:t>Repeat-customer satisfaction</a:t>
+            </a:r>
+          </a:p>
+        </p:txBody>
+      </p:sp>
+      <p:sp>
+        <p:nvSpPr>
+          <p:cNvPr id="20" name="Rounded Rectangle 19"/>
+          <p:cNvSpPr/>
+          <p:nvPr/>
+        </p:nvSpPr>
+        <p:spPr>
+          <a:xfrm>
+            <a:off x="7900416" y="1783080"/>
+            <a:ext cx="3401568" cy="1719072"/>
+          </a:xfrm>
+          <a:prstGeom prst="roundRect">
+            <a:avLst/>
+          </a:prstGeom>
+          <a:solidFill>
+            <a:srgbClr val="F5F8FC"/>
+          </a:solidFill>
+          <a:ln>
+            <a:solidFill>
+              <a:srgbClr val="E2E8F0"/>
+            </a:solidFill>
+          </a:ln>
+        </p:spPr>
+        <p:style>
+          <a:lnRef idx="1">
+            <a:schemeClr val="accent1"/>
+          </a:lnRef>
+          <a:fillRef idx="3">
+            <a:schemeClr val="accent1"/>
+          </a:fillRef>
+          <a:effectRef idx="2">
+            <a:schemeClr val="accent1"/>
+          </a:effectRef>
+          <a:fontRef idx="minor">
+            <a:schemeClr val="lt1"/>
+          </a:fontRef>
+        </p:style>
+        <p:txBody>
+          <a:bodyPr rtlCol="0" anchor="ctr"/>
+          <a:lstStyle/>
+          <a:p>
+            <a:pPr algn="ctr"/>
+          </a:p>
+        </p:txBody>
+      </p:sp>
+      <p:sp>
+        <p:nvSpPr>
+          <p:cNvPr id="21" name="Rectangle 20"/>
+          <p:cNvSpPr/>
+          <p:nvPr/>
+        </p:nvSpPr>
+        <p:spPr>
+          <a:xfrm>
+            <a:off x="7900416" y="1783080"/>
+            <a:ext cx="73152" cy="1719072"/>
+          </a:xfrm>
+          <a:prstGeom prst="rect">
+            <a:avLst/>
+          </a:prstGeom>
+          <a:solidFill>
+            <a:srgbClr val="7C3AED"/>
+          </a:solidFill>
+          <a:ln>
+            <a:solidFill>
+              <a:srgbClr val="7C3AED"/>
+            </a:solidFill>
+          </a:ln>
+        </p:spPr>
+        <p:style>
+          <a:lnRef idx="1">
+            <a:schemeClr val="accent1"/>
+          </a:lnRef>
+          <a:fillRef idx="3">
+            <a:schemeClr val="accent1"/>
+          </a:fillRef>
+          <a:effectRef idx="2">
+            <a:schemeClr val="accent1"/>
+          </a:effectRef>
+          <a:fontRef idx="minor">
+            <a:schemeClr val="lt1"/>
+          </a:fontRef>
+        </p:style>
+        <p:txBody>
+          <a:bodyPr rtlCol="0" anchor="ctr"/>
+          <a:lstStyle/>
+          <a:p>
+            <a:pPr algn="ctr"/>
+          </a:p>
+        </p:txBody>
+      </p:sp>
+      <p:sp>
+        <p:nvSpPr>
+          <p:cNvPr id="22" name="Rounded Rectangle 21"/>
+          <p:cNvSpPr/>
+          <p:nvPr/>
+        </p:nvSpPr>
+        <p:spPr>
+          <a:xfrm>
+            <a:off x="8101584" y="2002536"/>
+            <a:ext cx="438912" cy="438912"/>
+          </a:xfrm>
+          <a:prstGeom prst="roundRect">
+            <a:avLst/>
+          </a:prstGeom>
+          <a:solidFill>
+            <a:srgbClr val="7C3AED"/>
+          </a:solidFill>
+          <a:ln>
+            <a:solidFill>
+              <a:srgbClr val="7C3AED"/>
+            </a:solidFill>
+          </a:ln>
+        </p:spPr>
+        <p:style>
+          <a:lnRef idx="1">
+            <a:schemeClr val="accent1"/>
+          </a:lnRef>
+          <a:fillRef idx="3">
+            <a:schemeClr val="accent1"/>
+          </a:fillRef>
+          <a:effectRef idx="2">
+            <a:schemeClr val="accent1"/>
+          </a:effectRef>
+          <a:fontRef idx="minor">
+            <a:schemeClr val="lt1"/>
+          </a:fontRef>
+        </p:style>
+        <p:txBody>
+          <a:bodyPr rtlCol="0" anchor="ctr"/>
+          <a:lstStyle/>
+          <a:p>
+            <a:pPr algn="ctr"/>
+          </a:p>
+        </p:txBody>
+      </p:sp>
+      <p:sp>
+        <p:nvSpPr>
+          <p:cNvPr id="23" name="TextBox 22"/>
+          <p:cNvSpPr txBox="1"/>
+          <p:nvPr/>
+        </p:nvSpPr>
+        <p:spPr>
+          <a:xfrm>
+            <a:off x="8101584" y="2011680"/>
+            <a:ext cx="438912" cy="420624"/>
+          </a:xfrm>
+          <a:prstGeom prst="rect">
+            <a:avLst/>
+          </a:prstGeom>
+          <a:noFill/>
+        </p:spPr>
+        <p:txBody>
+          <a:bodyPr wrap="square" anchor="ctr">
+            <a:spAutoFit/>
+          </a:bodyPr>
+          <a:lstStyle/>
+          <a:p>
+            <a:pPr algn="ctr"/>
+            <a:r>
+              <a:rPr sz="1400" b="1">
+                <a:solidFill>
+                  <a:srgbClr val="FFFFFF"/>
+                </a:solidFill>
+                <a:latin typeface="Arial"/>
+              </a:rPr>
+              <a:t>3</a:t>
+            </a:r>
+          </a:p>
+        </p:txBody>
+      </p:sp>
+      <p:sp>
+        <p:nvSpPr>
+          <p:cNvPr id="24" name="TextBox 23"/>
+          <p:cNvSpPr txBox="1"/>
+          <p:nvPr/>
+        </p:nvSpPr>
+        <p:spPr>
+          <a:xfrm>
+            <a:off x="8705088" y="1965960"/>
+            <a:ext cx="2414016" cy="329184"/>
+          </a:xfrm>
+          <a:prstGeom prst="rect">
+            <a:avLst/>
+          </a:prstGeom>
+          <a:noFill/>
+        </p:spPr>
+        <p:txBody>
+          <a:bodyPr wrap="square" anchor="t">
+            <a:spAutoFit/>
+          </a:bodyPr>
+          <a:lstStyle/>
+          <a:p>
+            <a:pPr algn="l"/>
+            <a:r>
+              <a:rPr sz="1400" b="1">
+                <a:solidFill>
+                  <a:srgbClr val="7C3AED"/>
+                </a:solidFill>
+                <a:latin typeface="Arial"/>
+              </a:rPr>
+              <a:t>69%</a:t>
+            </a:r>
+          </a:p>
+        </p:txBody>
+      </p:sp>
+      <p:sp>
+        <p:nvSpPr>
+          <p:cNvPr id="25" name="TextBox 24"/>
+          <p:cNvSpPr txBox="1"/>
+          <p:nvPr/>
+        </p:nvSpPr>
+        <p:spPr>
+          <a:xfrm>
+            <a:off x="8705088" y="2350008"/>
+            <a:ext cx="2414016" cy="1005839"/>
+          </a:xfrm>
+          <a:prstGeom prst="rect">
+            <a:avLst/>
+          </a:prstGeom>
+          <a:noFill/>
+        </p:spPr>
+        <p:txBody>
+          <a:bodyPr wrap="square" anchor="t">
+            <a:spAutoFit/>
+          </a:bodyPr>
+          <a:lstStyle/>
+          <a:p>
+            <a:pPr algn="l"/>
+            <a:r>
+              <a:rPr sz="1150" b="0">
+                <a:solidFill>
+                  <a:srgbClr val="161B26"/>
+                </a:solidFill>
+                <a:latin typeface="Arial"/>
+              </a:rPr>
+              <a:t>First-time-customer satisfaction</a:t>
+            </a:r>
+          </a:p>
+        </p:txBody>
+      </p:sp>
+      <p:sp>
+        <p:nvSpPr>
+          <p:cNvPr id="26" name="Rounded Rectangle 25"/>
+          <p:cNvSpPr/>
+          <p:nvPr/>
+        </p:nvSpPr>
+        <p:spPr>
+          <a:xfrm>
+            <a:off x="731520" y="3776472"/>
+            <a:ext cx="3401568" cy="1719072"/>
+          </a:xfrm>
+          <a:prstGeom prst="roundRect">
+            <a:avLst/>
+          </a:prstGeom>
+          <a:solidFill>
+            <a:srgbClr val="F5F8FC"/>
+          </a:solidFill>
+          <a:ln>
+            <a:solidFill>
+              <a:srgbClr val="E2E8F0"/>
+            </a:solidFill>
+          </a:ln>
+        </p:spPr>
+        <p:style>
+          <a:lnRef idx="1">
+            <a:schemeClr val="accent1"/>
+          </a:lnRef>
+          <a:fillRef idx="3">
+            <a:schemeClr val="accent1"/>
+          </a:fillRef>
+          <a:effectRef idx="2">
+            <a:schemeClr val="accent1"/>
+          </a:effectRef>
+          <a:fontRef idx="minor">
+            <a:schemeClr val="lt1"/>
+          </a:fontRef>
+        </p:style>
+        <p:txBody>
+          <a:bodyPr rtlCol="0" anchor="ctr"/>
+          <a:lstStyle/>
+          <a:p>
+            <a:pPr algn="ctr"/>
+          </a:p>
+        </p:txBody>
+      </p:sp>
+      <p:sp>
+        <p:nvSpPr>
+          <p:cNvPr id="27" name="Rectangle 26"/>
+          <p:cNvSpPr/>
+          <p:nvPr/>
+        </p:nvSpPr>
+        <p:spPr>
+          <a:xfrm>
+            <a:off x="731520" y="3776472"/>
+            <a:ext cx="73152" cy="1719072"/>
+          </a:xfrm>
+          <a:prstGeom prst="rect">
+            <a:avLst/>
+          </a:prstGeom>
+          <a:solidFill>
+            <a:srgbClr val="F59E0B"/>
+          </a:solidFill>
+          <a:ln>
+            <a:solidFill>
+              <a:srgbClr val="F59E0B"/>
+            </a:solidFill>
+          </a:ln>
+        </p:spPr>
+        <p:style>
+          <a:lnRef idx="1">
+            <a:schemeClr val="accent1"/>
+          </a:lnRef>
+          <a:fillRef idx="3">
+            <a:schemeClr val="accent1"/>
+          </a:fillRef>
+          <a:effectRef idx="2">
+            <a:schemeClr val="accent1"/>
+          </a:effectRef>
+          <a:fontRef idx="minor">
+            <a:schemeClr val="lt1"/>
+          </a:fontRef>
+        </p:style>
+        <p:txBody>
+          <a:bodyPr rtlCol="0" anchor="ctr"/>
+          <a:lstStyle/>
+          <a:p>
+            <a:pPr algn="ctr"/>
+          </a:p>
+        </p:txBody>
+      </p:sp>
+      <p:sp>
+        <p:nvSpPr>
+          <p:cNvPr id="28" name="Rounded Rectangle 27"/>
+          <p:cNvSpPr/>
+          <p:nvPr/>
+        </p:nvSpPr>
+        <p:spPr>
+          <a:xfrm>
+            <a:off x="932688" y="3995928"/>
+            <a:ext cx="438912" cy="438912"/>
+          </a:xfrm>
+          <a:prstGeom prst="roundRect">
+            <a:avLst/>
+          </a:prstGeom>
+          <a:solidFill>
+            <a:srgbClr val="F59E0B"/>
+          </a:solidFill>
+          <a:ln>
+            <a:solidFill>
+              <a:srgbClr val="F59E0B"/>
+            </a:solidFill>
+          </a:ln>
+        </p:spPr>
+        <p:style>
+          <a:lnRef idx="1">
+            <a:schemeClr val="accent1"/>
+          </a:lnRef>
+          <a:fillRef idx="3">
+            <a:schemeClr val="accent1"/>
+          </a:fillRef>
+          <a:effectRef idx="2">
+            <a:schemeClr val="accent1"/>
+          </a:effectRef>
+          <a:fontRef idx="minor">
+            <a:schemeClr val="lt1"/>
+          </a:fontRef>
+        </p:style>
+        <p:txBody>
+          <a:bodyPr rtlCol="0" anchor="ctr"/>
+          <a:lstStyle/>
+          <a:p>
+            <a:pPr algn="ctr"/>
+          </a:p>
+        </p:txBody>
+      </p:sp>
+      <p:sp>
+        <p:nvSpPr>
+          <p:cNvPr id="29" name="TextBox 28"/>
+          <p:cNvSpPr txBox="1"/>
+          <p:nvPr/>
+        </p:nvSpPr>
+        <p:spPr>
+          <a:xfrm>
+            <a:off x="932688" y="4005072"/>
+            <a:ext cx="438912" cy="420624"/>
+          </a:xfrm>
+          <a:prstGeom prst="rect">
+            <a:avLst/>
+          </a:prstGeom>
+          <a:noFill/>
+        </p:spPr>
+        <p:txBody>
+          <a:bodyPr wrap="square" anchor="ctr">
+            <a:spAutoFit/>
+          </a:bodyPr>
+          <a:lstStyle/>
+          <a:p>
+            <a:pPr algn="ctr"/>
+            <a:r>
+              <a:rPr sz="1400" b="1">
+                <a:solidFill>
+                  <a:srgbClr val="FFFFFF"/>
+                </a:solidFill>
+                <a:latin typeface="Arial"/>
+              </a:rPr>
+              <a:t>4</a:t>
+            </a:r>
+          </a:p>
+        </p:txBody>
+      </p:sp>
+      <p:sp>
+        <p:nvSpPr>
+          <p:cNvPr id="30" name="TextBox 29"/>
+          <p:cNvSpPr txBox="1"/>
+          <p:nvPr/>
+        </p:nvSpPr>
+        <p:spPr>
+          <a:xfrm>
+            <a:off x="1536192" y="3959352"/>
+            <a:ext cx="2414016" cy="329184"/>
+          </a:xfrm>
+          <a:prstGeom prst="rect">
+            <a:avLst/>
+          </a:prstGeom>
+          <a:noFill/>
+        </p:spPr>
+        <p:txBody>
+          <a:bodyPr wrap="square" anchor="t">
+            <a:spAutoFit/>
+          </a:bodyPr>
+          <a:lstStyle/>
+          <a:p>
+            <a:pPr algn="l"/>
+            <a:r>
+              <a:rPr sz="1400" b="1">
+                <a:solidFill>
+                  <a:srgbClr val="F59E0B"/>
+                </a:solidFill>
+                <a:latin typeface="Arial"/>
+              </a:rPr>
+              <a:t>+11 pts</a:t>
+            </a:r>
+          </a:p>
+        </p:txBody>
+      </p:sp>
+      <p:sp>
+        <p:nvSpPr>
+          <p:cNvPr id="31" name="TextBox 30"/>
+          <p:cNvSpPr txBox="1"/>
+          <p:nvPr/>
+        </p:nvSpPr>
+        <p:spPr>
+          <a:xfrm>
+            <a:off x="1536192" y="4343400"/>
+            <a:ext cx="2414016" cy="1005839"/>
+          </a:xfrm>
+          <a:prstGeom prst="rect">
+            <a:avLst/>
+          </a:prstGeom>
+          <a:noFill/>
+        </p:spPr>
+        <p:txBody>
+          <a:bodyPr wrap="square" anchor="t">
+            <a:spAutoFit/>
+          </a:bodyPr>
+          <a:lstStyle/>
+          <a:p>
+            <a:pPr algn="l"/>
+            <a:r>
+              <a:rPr sz="1150" b="0">
+                <a:solidFill>
+                  <a:srgbClr val="161B26"/>
+                </a:solidFill>
+                <a:latin typeface="Arial"/>
+              </a:rPr>
+              <a:t>Mobile-app users vs non-users</a:t>
+            </a:r>
+          </a:p>
+        </p:txBody>
+      </p:sp>
+      <p:sp>
+        <p:nvSpPr>
+          <p:cNvPr id="32" name="Rounded Rectangle 31"/>
+          <p:cNvSpPr/>
+          <p:nvPr/>
+        </p:nvSpPr>
+        <p:spPr>
+          <a:xfrm>
+            <a:off x="4315968" y="3776472"/>
+            <a:ext cx="3401568" cy="1719072"/>
+          </a:xfrm>
+          <a:prstGeom prst="roundRect">
+            <a:avLst/>
+          </a:prstGeom>
+          <a:solidFill>
+            <a:srgbClr val="F5F8FC"/>
+          </a:solidFill>
+          <a:ln>
+            <a:solidFill>
+              <a:srgbClr val="E2E8F0"/>
+            </a:solidFill>
+          </a:ln>
+        </p:spPr>
+        <p:style>
+          <a:lnRef idx="1">
+            <a:schemeClr val="accent1"/>
+          </a:lnRef>
+          <a:fillRef idx="3">
+            <a:schemeClr val="accent1"/>
+          </a:fillRef>
+          <a:effectRef idx="2">
+            <a:schemeClr val="accent1"/>
+          </a:effectRef>
+          <a:fontRef idx="minor">
+            <a:schemeClr val="lt1"/>
+          </a:fontRef>
+        </p:style>
+        <p:txBody>
+          <a:bodyPr rtlCol="0" anchor="ctr"/>
+          <a:lstStyle/>
+          <a:p>
+            <a:pPr algn="ctr"/>
+          </a:p>
+        </p:txBody>
+      </p:sp>
+      <p:sp>
+        <p:nvSpPr>
+          <p:cNvPr id="33" name="Rectangle 32"/>
+          <p:cNvSpPr/>
+          <p:nvPr/>
+        </p:nvSpPr>
+        <p:spPr>
+          <a:xfrm>
+            <a:off x="4315968" y="3776472"/>
+            <a:ext cx="73152" cy="1719072"/>
+          </a:xfrm>
+          <a:prstGeom prst="rect">
+            <a:avLst/>
+          </a:prstGeom>
+          <a:solidFill>
+            <a:srgbClr val="1F6FEB"/>
+          </a:solidFill>
+          <a:ln>
+            <a:solidFill>
+              <a:srgbClr val="1F6FEB"/>
+            </a:solidFill>
+          </a:ln>
+        </p:spPr>
+        <p:style>
+          <a:lnRef idx="1">
+            <a:schemeClr val="accent1"/>
+          </a:lnRef>
+          <a:fillRef idx="3">
+            <a:schemeClr val="accent1"/>
+          </a:fillRef>
+          <a:effectRef idx="2">
+            <a:schemeClr val="accent1"/>
+          </a:effectRef>
+          <a:fontRef idx="minor">
+            <a:schemeClr val="lt1"/>
+          </a:fontRef>
+        </p:style>
+        <p:txBody>
+          <a:bodyPr rtlCol="0" anchor="ctr"/>
+          <a:lstStyle/>
+          <a:p>
+            <a:pPr algn="ctr"/>
+          </a:p>
+        </p:txBody>
+      </p:sp>
+      <p:sp>
+        <p:nvSpPr>
+          <p:cNvPr id="34" name="Rounded Rectangle 33"/>
+          <p:cNvSpPr/>
+          <p:nvPr/>
+        </p:nvSpPr>
+        <p:spPr>
+          <a:xfrm>
+            <a:off x="4517136" y="3995928"/>
+            <a:ext cx="438912" cy="438912"/>
+          </a:xfrm>
+          <a:prstGeom prst="roundRect">
+            <a:avLst/>
+          </a:prstGeom>
+          <a:solidFill>
+            <a:srgbClr val="1F6FEB"/>
+          </a:solidFill>
+          <a:ln>
+            <a:solidFill>
+              <a:srgbClr val="1F6FEB"/>
+            </a:solidFill>
+          </a:ln>
+        </p:spPr>
+        <p:style>
+          <a:lnRef idx="1">
+            <a:schemeClr val="accent1"/>
+          </a:lnRef>
+          <a:fillRef idx="3">
+            <a:schemeClr val="accent1"/>
+          </a:fillRef>
+          <a:effectRef idx="2">
+            <a:schemeClr val="accent1"/>
+          </a:effectRef>
+          <a:fontRef idx="minor">
+            <a:schemeClr val="lt1"/>
+          </a:fontRef>
+        </p:style>
+        <p:txBody>
+          <a:bodyPr rtlCol="0" anchor="ctr"/>
+          <a:lstStyle/>
+          <a:p>
+            <a:pPr algn="ctr"/>
+          </a:p>
+        </p:txBody>
+      </p:sp>
+      <p:sp>
+        <p:nvSpPr>
+          <p:cNvPr id="35" name="TextBox 34"/>
+          <p:cNvSpPr txBox="1"/>
+          <p:nvPr/>
+        </p:nvSpPr>
+        <p:spPr>
+          <a:xfrm>
+            <a:off x="4517136" y="4005072"/>
+            <a:ext cx="438912" cy="420624"/>
+          </a:xfrm>
+          <a:prstGeom prst="rect">
+            <a:avLst/>
+          </a:prstGeom>
+          <a:noFill/>
+        </p:spPr>
+        <p:txBody>
+          <a:bodyPr wrap="square" anchor="ctr">
+            <a:spAutoFit/>
+          </a:bodyPr>
+          <a:lstStyle/>
+          <a:p>
+            <a:pPr algn="ctr"/>
+            <a:r>
+              <a:rPr sz="1400" b="1">
+                <a:solidFill>
+                  <a:srgbClr val="FFFFFF"/>
+                </a:solidFill>
+                <a:latin typeface="Arial"/>
+              </a:rPr>
+              <a:t>5</a:t>
+            </a:r>
+          </a:p>
+        </p:txBody>
+      </p:sp>
+      <p:sp>
+        <p:nvSpPr>
+          <p:cNvPr id="36" name="TextBox 35"/>
+          <p:cNvSpPr txBox="1"/>
+          <p:nvPr/>
+        </p:nvSpPr>
+        <p:spPr>
+          <a:xfrm>
+            <a:off x="5120640" y="3959352"/>
+            <a:ext cx="2414016" cy="329184"/>
+          </a:xfrm>
+          <a:prstGeom prst="rect">
+            <a:avLst/>
+          </a:prstGeom>
+          <a:noFill/>
+        </p:spPr>
+        <p:txBody>
+          <a:bodyPr wrap="square" anchor="t">
+            <a:spAutoFit/>
+          </a:bodyPr>
+          <a:lstStyle/>
+          <a:p>
+            <a:pPr algn="l"/>
+            <a:r>
+              <a:rPr sz="1400" b="1">
+                <a:solidFill>
+                  <a:srgbClr val="1F6FEB"/>
+                </a:solidFill>
+                <a:latin typeface="Arial"/>
+              </a:rPr>
+              <a:t>420</a:t>
+            </a:r>
+          </a:p>
+        </p:txBody>
+      </p:sp>
+      <p:sp>
+        <p:nvSpPr>
+          <p:cNvPr id="37" name="TextBox 36"/>
+          <p:cNvSpPr txBox="1"/>
+          <p:nvPr/>
+        </p:nvSpPr>
+        <p:spPr>
+          <a:xfrm>
+            <a:off x="5120640" y="4343400"/>
+            <a:ext cx="2414016" cy="1005839"/>
+          </a:xfrm>
+          <a:prstGeom prst="rect">
+            <a:avLst/>
+          </a:prstGeom>
+          <a:noFill/>
+        </p:spPr>
+        <p:txBody>
+          <a:bodyPr wrap="square" anchor="t">
+            <a:spAutoFit/>
+          </a:bodyPr>
+          <a:lstStyle/>
+          <a:p>
+            <a:pPr algn="l"/>
+            <a:r>
+              <a:rPr sz="1150" b="0">
+                <a:solidFill>
+                  <a:srgbClr val="161B26"/>
+                </a:solidFill>
+                <a:latin typeface="Arial"/>
+              </a:rPr>
+              <a:t>Survey responses</a:t>
+            </a:r>
+          </a:p>
+        </p:txBody>
+      </p:sp>
+      <p:sp>
+        <p:nvSpPr>
+          <p:cNvPr id="38" name="Rounded Rectangle 37"/>
+          <p:cNvSpPr/>
+          <p:nvPr/>
+        </p:nvSpPr>
+        <p:spPr>
+          <a:xfrm>
+            <a:off x="7900416" y="3776472"/>
+            <a:ext cx="3401568" cy="1719072"/>
+          </a:xfrm>
+          <a:prstGeom prst="roundRect">
+            <a:avLst/>
+          </a:prstGeom>
+          <a:solidFill>
+            <a:srgbClr val="F5F8FC"/>
+          </a:solidFill>
+          <a:ln>
+            <a:solidFill>
+              <a:srgbClr val="E2E8F0"/>
+            </a:solidFill>
+          </a:ln>
+        </p:spPr>
+        <p:style>
+          <a:lnRef idx="1">
+            <a:schemeClr val="accent1"/>
+          </a:lnRef>
+          <a:fillRef idx="3">
+            <a:schemeClr val="accent1"/>
+          </a:fillRef>
+          <a:effectRef idx="2">
+            <a:schemeClr val="accent1"/>
+          </a:effectRef>
+          <a:fontRef idx="minor">
+            <a:schemeClr val="lt1"/>
+          </a:fontRef>
+        </p:style>
+        <p:txBody>
+          <a:bodyPr rtlCol="0" anchor="ctr"/>
+          <a:lstStyle/>
+          <a:p>
+            <a:pPr algn="ctr"/>
+          </a:p>
+        </p:txBody>
+      </p:sp>
+      <p:sp>
+        <p:nvSpPr>
+          <p:cNvPr id="39" name="Rectangle 38"/>
+          <p:cNvSpPr/>
+          <p:nvPr/>
+        </p:nvSpPr>
+        <p:spPr>
+          <a:xfrm>
+            <a:off x="7900416" y="3776472"/>
+            <a:ext cx="73152" cy="1719072"/>
+          </a:xfrm>
+          <a:prstGeom prst="rect">
+            <a:avLst/>
+          </a:prstGeom>
+          <a:solidFill>
+            <a:srgbClr val="10B981"/>
+          </a:solidFill>
+          <a:ln>
+            <a:solidFill>
+              <a:srgbClr val="10B981"/>
+            </a:solidFill>
+          </a:ln>
+        </p:spPr>
+        <p:style>
+          <a:lnRef idx="1">
+            <a:schemeClr val="accent1"/>
+          </a:lnRef>
+          <a:fillRef idx="3">
+            <a:schemeClr val="accent1"/>
+          </a:fillRef>
+          <a:effectRef idx="2">
+            <a:schemeClr val="accent1"/>
+          </a:effectRef>
+          <a:fontRef idx="minor">
+            <a:schemeClr val="lt1"/>
+          </a:fontRef>
+        </p:style>
+        <p:txBody>
+          <a:bodyPr rtlCol="0" anchor="ctr"/>
+          <a:lstStyle/>
+          <a:p>
+            <a:pPr algn="ctr"/>
+          </a:p>
+        </p:txBody>
+      </p:sp>
+      <p:sp>
+        <p:nvSpPr>
+          <p:cNvPr id="40" name="Rounded Rectangle 39"/>
+          <p:cNvSpPr/>
+          <p:nvPr/>
+        </p:nvSpPr>
+        <p:spPr>
+          <a:xfrm>
+            <a:off x="8101584" y="3995928"/>
+            <a:ext cx="438912" cy="438912"/>
+          </a:xfrm>
+          <a:prstGeom prst="roundRect">
+            <a:avLst/>
+          </a:prstGeom>
+          <a:solidFill>
+            <a:srgbClr val="10B981"/>
+          </a:solidFill>
+          <a:ln>
+            <a:solidFill>
+              <a:srgbClr val="10B981"/>
+            </a:solidFill>
+          </a:ln>
+        </p:spPr>
+        <p:style>
+          <a:lnRef idx="1">
+            <a:schemeClr val="accent1"/>
+          </a:lnRef>
+          <a:fillRef idx="3">
+            <a:schemeClr val="accent1"/>
+          </a:fillRef>
+          <a:effectRef idx="2">
+            <a:schemeClr val="accent1"/>
+          </a:effectRef>
+          <a:fontRef idx="minor">
+            <a:schemeClr val="lt1"/>
+          </a:fontRef>
+        </p:style>
+        <p:txBody>
+          <a:bodyPr rtlCol="0" anchor="ctr"/>
+          <a:lstStyle/>
+          <a:p>
+            <a:pPr algn="ctr"/>
+          </a:p>
+        </p:txBody>
+      </p:sp>
+      <p:sp>
+        <p:nvSpPr>
+          <p:cNvPr id="41" name="TextBox 40"/>
+          <p:cNvSpPr txBox="1"/>
+          <p:nvPr/>
+        </p:nvSpPr>
+        <p:spPr>
+          <a:xfrm>
+            <a:off x="8101584" y="4005072"/>
+            <a:ext cx="438912" cy="420624"/>
+          </a:xfrm>
+          <a:prstGeom prst="rect">
+            <a:avLst/>
+          </a:prstGeom>
+          <a:noFill/>
+        </p:spPr>
+        <p:txBody>
+          <a:bodyPr wrap="square" anchor="ctr">
+            <a:spAutoFit/>
+          </a:bodyPr>
+          <a:lstStyle/>
+          <a:p>
+            <a:pPr algn="ctr"/>
+            <a:r>
+              <a:rPr sz="1400" b="1">
+                <a:solidFill>
+                  <a:srgbClr val="FFFFFF"/>
+                </a:solidFill>
+                <a:latin typeface="Arial"/>
+              </a:rPr>
+              <a:t>6</a:t>
+            </a:r>
+          </a:p>
+        </p:txBody>
+      </p:sp>
+      <p:sp>
+        <p:nvSpPr>
+          <p:cNvPr id="42" name="TextBox 41"/>
+          <p:cNvSpPr txBox="1"/>
+          <p:nvPr/>
+        </p:nvSpPr>
+        <p:spPr>
+          <a:xfrm>
+            <a:off x="8705088" y="3959352"/>
+            <a:ext cx="2414016" cy="329184"/>
+          </a:xfrm>
+          <a:prstGeom prst="rect">
+            <a:avLst/>
+          </a:prstGeom>
+          <a:noFill/>
+        </p:spPr>
+        <p:txBody>
+          <a:bodyPr wrap="square" anchor="t">
+            <a:spAutoFit/>
+          </a:bodyPr>
+          <a:lstStyle/>
+          <a:p>
+            <a:pPr algn="l"/>
+            <a:r>
+              <a:rPr sz="1400" b="1">
+                <a:solidFill>
+                  <a:srgbClr val="10B981"/>
+                </a:solidFill>
+                <a:latin typeface="Arial"/>
+              </a:rPr>
+              <a:t>Q2 2026</a:t>
+            </a:r>
+          </a:p>
+        </p:txBody>
+      </p:sp>
+      <p:sp>
+        <p:nvSpPr>
+          <p:cNvPr id="43" name="TextBox 42"/>
+          <p:cNvSpPr txBox="1"/>
+          <p:nvPr/>
+        </p:nvSpPr>
+        <p:spPr>
+          <a:xfrm>
+            <a:off x="8705088" y="4343400"/>
+            <a:ext cx="2414016" cy="1005839"/>
+          </a:xfrm>
+          <a:prstGeom prst="rect">
+            <a:avLst/>
+          </a:prstGeom>
+          <a:noFill/>
+        </p:spPr>
+        <p:txBody>
+          <a:bodyPr wrap="square" anchor="t">
+            <a:spAutoFit/>
+          </a:bodyPr>
+          <a:lstStyle/>
+          <a:p>
+            <a:pPr algn="l"/>
+            <a:r>
+              <a:rPr sz="1150" b="0">
+                <a:solidFill>
+                  <a:srgbClr val="161B26"/>
+                </a:solidFill>
+                <a:latin typeface="Arial"/>
+              </a:rPr>
+              <a:t>Synthetic reporting period</a:t>
+            </a:r>
+          </a:p>
+        </p:txBody>
+      </p:sp>
+    </p:spTree>
+  </p:cSld>
+  <p:clrMapOvr>
+    <a:masterClrMapping/>
+  </p:clrMapOvr>
+</p:sld>
+</file>
+
+<file path=ppt/slides/slide7.xml><?xml version="1.0" encoding="utf-8"?>
+<p:sld xmlns:a="http://schemas.openxmlformats.org/drawingml/2006/main" xmlns:p="http://schemas.openxmlformats.org/presentationml/2006/main" xmlns:r="http://schemas.openxmlformats.org/officeDocument/2006/relationships">
+  <p:cSld>
+    <p:spTree>
+      <p:nvGrpSpPr>
+        <p:cNvPr id="1" name=""/>
+        <p:cNvGrpSpPr/>
+        <p:nvPr/>
+      </p:nvGrpSpPr>
+      <p:grpSpPr/>
+      <p:sp>
+        <p:nvSpPr>
+          <p:cNvPr id="2" name="Rectangle 1"/>
+          <p:cNvSpPr/>
+          <p:nvPr/>
+        </p:nvSpPr>
+        <p:spPr>
+          <a:xfrm>
+            <a:off x="0" y="0"/>
+            <a:ext cx="12191695" cy="6858000"/>
+          </a:xfrm>
+          <a:prstGeom prst="rect">
+            <a:avLst/>
+          </a:prstGeom>
+          <a:solidFill>
+            <a:srgbClr val="FFFFFF"/>
+          </a:solidFill>
+          <a:ln>
+            <a:solidFill>
+              <a:srgbClr val="FFFFFF"/>
+            </a:solidFill>
+          </a:ln>
+        </p:spPr>
+        <p:style>
+          <a:lnRef idx="1">
+            <a:schemeClr val="accent1"/>
+          </a:lnRef>
+          <a:fillRef idx="3">
+            <a:schemeClr val="accent1"/>
+          </a:fillRef>
+          <a:effectRef idx="2">
+            <a:schemeClr val="accent1"/>
+          </a:effectRef>
+          <a:fontRef idx="minor">
+            <a:schemeClr val="lt1"/>
+          </a:fontRef>
+        </p:style>
+        <p:txBody>
+          <a:bodyPr rtlCol="0" anchor="ctr"/>
+          <a:lstStyle/>
+          <a:p>
+            <a:pPr algn="ctr"/>
+          </a:p>
+        </p:txBody>
+      </p:sp>
+      <p:sp>
+        <p:nvSpPr>
+          <p:cNvPr id="3" name="Rectangle 2"/>
+          <p:cNvSpPr/>
+          <p:nvPr/>
+        </p:nvSpPr>
+        <p:spPr>
+          <a:xfrm>
+            <a:off x="0" y="0"/>
+            <a:ext cx="164592" cy="6858000"/>
+          </a:xfrm>
+          <a:prstGeom prst="rect">
+            <a:avLst/>
+          </a:prstGeom>
+          <a:solidFill>
+            <a:srgbClr val="1F6FEB"/>
+          </a:solidFill>
+          <a:ln>
+            <a:solidFill>
+              <a:srgbClr val="1F6FEB"/>
+            </a:solidFill>
+          </a:ln>
+        </p:spPr>
+        <p:style>
+          <a:lnRef idx="1">
+            <a:schemeClr val="accent1"/>
+          </a:lnRef>
+          <a:fillRef idx="3">
+            <a:schemeClr val="accent1"/>
+          </a:fillRef>
+          <a:effectRef idx="2">
+            <a:schemeClr val="accent1"/>
+          </a:effectRef>
+          <a:fontRef idx="minor">
+            <a:schemeClr val="lt1"/>
+          </a:fontRef>
+        </p:style>
+        <p:txBody>
+          <a:bodyPr rtlCol="0" anchor="ctr"/>
+          <a:lstStyle/>
+          <a:p>
+            <a:pPr algn="ctr"/>
+          </a:p>
+        </p:txBody>
+      </p:sp>
+      <p:sp>
+        <p:nvSpPr>
+          <p:cNvPr id="4" name="TextBox 3"/>
+          <p:cNvSpPr txBox="1"/>
+          <p:nvPr/>
+        </p:nvSpPr>
+        <p:spPr>
+          <a:xfrm>
+            <a:off x="658368" y="384048"/>
+            <a:ext cx="10789920" cy="320040"/>
+          </a:xfrm>
+          <a:prstGeom prst="rect">
+            <a:avLst/>
+          </a:prstGeom>
+          <a:noFill/>
+        </p:spPr>
+        <p:txBody>
+          <a:bodyPr wrap="square" anchor="t">
+            <a:spAutoFit/>
+          </a:bodyPr>
+          <a:lstStyle/>
+          <a:p>
+            <a:pPr algn="l"/>
+            <a:r>
+              <a:rPr sz="1100" b="1">
+                <a:solidFill>
+                  <a:srgbClr val="1F6FEB"/>
+                </a:solidFill>
+                <a:latin typeface="Arial"/>
+              </a:rPr>
+              <a:t>ACTIVITY 01 · ACCEPTANCE</a:t>
+            </a:r>
+          </a:p>
+        </p:txBody>
+      </p:sp>
+      <p:sp>
+        <p:nvSpPr>
+          <p:cNvPr id="5" name="TextBox 4"/>
+          <p:cNvSpPr txBox="1"/>
+          <p:nvPr/>
+        </p:nvSpPr>
+        <p:spPr>
+          <a:xfrm>
+            <a:off x="658368" y="749808"/>
+            <a:ext cx="10789920" cy="658368"/>
+          </a:xfrm>
+          <a:prstGeom prst="rect">
+            <a:avLst/>
+          </a:prstGeom>
+          <a:noFill/>
+        </p:spPr>
+        <p:txBody>
+          <a:bodyPr wrap="square" anchor="t">
+            <a:spAutoFit/>
+          </a:bodyPr>
+          <a:lstStyle/>
+          <a:p>
+            <a:pPr algn="l"/>
+            <a:r>
+              <a:rPr sz="2700" b="1">
+                <a:solidFill>
+                  <a:srgbClr val="161B26"/>
+                </a:solidFill>
+                <a:latin typeface="Arial"/>
+              </a:rPr>
+              <a:t>What Good Looks Like</a:t>
+            </a:r>
+          </a:p>
+        </p:txBody>
+      </p:sp>
+      <p:sp>
+        <p:nvSpPr>
+          <p:cNvPr id="6" name="Rectangle 5"/>
+          <p:cNvSpPr/>
+          <p:nvPr/>
+        </p:nvSpPr>
+        <p:spPr>
+          <a:xfrm>
+            <a:off x="658368" y="1444752"/>
+            <a:ext cx="10881360" cy="18288"/>
+          </a:xfrm>
+          <a:prstGeom prst="rect">
+            <a:avLst/>
+          </a:prstGeom>
+          <a:solidFill>
+            <a:srgbClr val="E2E8F0"/>
+          </a:solidFill>
+          <a:ln>
+            <a:solidFill>
+              <a:srgbClr val="E2E8F0"/>
+            </a:solidFill>
+          </a:ln>
+        </p:spPr>
+        <p:style>
+          <a:lnRef idx="1">
+            <a:schemeClr val="accent1"/>
+          </a:lnRef>
+          <a:fillRef idx="3">
+            <a:schemeClr val="accent1"/>
+          </a:fillRef>
+          <a:effectRef idx="2">
+            <a:schemeClr val="accent1"/>
+          </a:effectRef>
+          <a:fontRef idx="minor">
+            <a:schemeClr val="lt1"/>
+          </a:fontRef>
+        </p:style>
+        <p:txBody>
+          <a:bodyPr rtlCol="0" anchor="ctr"/>
+          <a:lstStyle/>
+          <a:p>
+            <a:pPr algn="ctr"/>
+          </a:p>
+        </p:txBody>
+      </p:sp>
+      <p:sp>
+        <p:nvSpPr>
+          <p:cNvPr id="7" name="TextBox 6"/>
+          <p:cNvSpPr txBox="1"/>
+          <p:nvPr/>
+        </p:nvSpPr>
+        <p:spPr>
+          <a:xfrm>
+            <a:off x="658368" y="6473952"/>
+            <a:ext cx="9875520" cy="201168"/>
+          </a:xfrm>
+          <a:prstGeom prst="rect">
+            <a:avLst/>
+          </a:prstGeom>
+          <a:noFill/>
+        </p:spPr>
+        <p:txBody>
+          <a:bodyPr wrap="square" anchor="t">
+            <a:spAutoFit/>
+          </a:bodyPr>
+          <a:lstStyle/>
+          <a:p>
+            <a:pPr algn="l"/>
+            <a:r>
+              <a:rPr sz="800" b="0">
+                <a:solidFill>
+                  <a:srgbClr val="5B6372"/>
+                </a:solidFill>
+                <a:latin typeface="Arial"/>
+              </a:rPr>
+              <a:t>TGS-2026064178 · ACTIVITY PRACTICE · Tertiary Infotech Academy Pte Ltd</a:t>
+            </a:r>
+          </a:p>
+        </p:txBody>
+      </p:sp>
+      <p:sp>
+        <p:nvSpPr>
+          <p:cNvPr id="8" name="Rounded Rectangle 7"/>
+          <p:cNvSpPr/>
+          <p:nvPr/>
+        </p:nvSpPr>
+        <p:spPr>
+          <a:xfrm>
+            <a:off x="749808" y="1810512"/>
+            <a:ext cx="10652760" cy="1005840"/>
+          </a:xfrm>
+          <a:prstGeom prst="roundRect">
+            <a:avLst/>
+          </a:prstGeom>
+          <a:solidFill>
+            <a:srgbClr val="1F6FEB"/>
+          </a:solidFill>
+          <a:ln>
+            <a:solidFill>
+              <a:srgbClr val="1F6FEB"/>
+            </a:solidFill>
+          </a:ln>
+        </p:spPr>
+        <p:style>
+          <a:lnRef idx="1">
+            <a:schemeClr val="accent1"/>
+          </a:lnRef>
+          <a:fillRef idx="3">
+            <a:schemeClr val="accent1"/>
+          </a:fillRef>
+          <a:effectRef idx="2">
+            <a:schemeClr val="accent1"/>
+          </a:effectRef>
+          <a:fontRef idx="minor">
+            <a:schemeClr val="lt1"/>
+          </a:fontRef>
+        </p:style>
+        <p:txBody>
+          <a:bodyPr rtlCol="0" anchor="ctr"/>
+          <a:lstStyle/>
+          <a:p>
+            <a:pPr algn="ctr"/>
+          </a:p>
+        </p:txBody>
+      </p:sp>
+      <p:sp>
+        <p:nvSpPr>
+          <p:cNvPr id="9" name="TextBox 8"/>
+          <p:cNvSpPr txBox="1"/>
+          <p:nvPr/>
+        </p:nvSpPr>
+        <p:spPr>
+          <a:xfrm>
+            <a:off x="1051560" y="2011680"/>
+            <a:ext cx="10058400" cy="566928"/>
+          </a:xfrm>
+          <a:prstGeom prst="rect">
+            <a:avLst/>
+          </a:prstGeom>
+          <a:noFill/>
+        </p:spPr>
+        <p:txBody>
+          <a:bodyPr wrap="square" anchor="ctr">
+            <a:spAutoFit/>
+          </a:bodyPr>
+          <a:lstStyle/>
+          <a:p>
+            <a:pPr algn="ctr"/>
+            <a:r>
+              <a:rPr sz="1900" b="1">
+                <a:solidFill>
+                  <a:srgbClr val="FFFFFF"/>
+                </a:solidFill>
+                <a:latin typeface="Arial"/>
+              </a:rPr>
+              <a:t>A verified statistical KPI infographic, prompt/source log, annotated insight slide and one-sentence recommendation</a:t>
             </a:r>
           </a:p>
         </p:txBody>

</xml_diff>